<commit_message>
Upgrade Activity 1 presentation deck
Revise the Activity 1 deck with a weighted alternative matrix, explicit robot shortlist, updated budget and ROI figures, regenerated PDF slides, image-backed PPTX, and native editable PPTX.
</commit_message>
<xml_diff>
--- a/actividad1/slides/Actividad1_AMR_FOD_Kitting_editable.pptx
+++ b/actividad1/slides/Actividad1_AMR_FOD_Kitting_editable.pptx
@@ -5480,7 +5480,7 @@
                 <a:ea typeface="Aptos" pitchFamily="34" charset="-122"/>
                 <a:cs typeface="Aptos" pitchFamily="34" charset="-120"/>
               </a:rPr>
-              <a:t>198.688 € CAPEX</a:t>
+              <a:t>219.856 € CAPEX</a:t>
             </a:r>
             <a:endParaRPr lang="en-US" sz="830" dirty="0"/>
           </a:p>
@@ -5794,7 +5794,7 @@
                 <a:ea typeface="Aptos" pitchFamily="34" charset="-122"/>
                 <a:cs typeface="Aptos" pitchFamily="34" charset="-120"/>
               </a:rPr>
-              <a:t>904.736 € CAPEX</a:t>
+              <a:t>1.018.752 € CAPEX</a:t>
             </a:r>
             <a:endParaRPr lang="en-US" sz="830" dirty="0"/>
           </a:p>
@@ -6108,7 +6108,7 @@
                 <a:ea typeface="Aptos" pitchFamily="34" charset="-122"/>
                 <a:cs typeface="Aptos" pitchFamily="34" charset="-120"/>
               </a:rPr>
-              <a:t>2.051.616 € CAPEX</a:t>
+              <a:t>2.310.896 € CAPEX</a:t>
             </a:r>
             <a:endParaRPr lang="en-US" sz="830" dirty="0"/>
           </a:p>
@@ -6688,7 +6688,7 @@
                 <a:ea typeface="Aptos" pitchFamily="34" charset="-122"/>
                 <a:cs typeface="Aptos" pitchFamily="34" charset="-120"/>
               </a:rPr>
-              <a:t>198.688 €</a:t>
+              <a:t>219.856 €</a:t>
             </a:r>
             <a:endParaRPr lang="en-US" sz="1380" dirty="0"/>
           </a:p>
@@ -6770,7 +6770,7 @@
                 <a:ea typeface="Aptos" pitchFamily="34" charset="-122"/>
                 <a:cs typeface="Aptos" pitchFamily="34" charset="-120"/>
               </a:rPr>
-              <a:t>904.736 €</a:t>
+              <a:t>1.018.752 €</a:t>
             </a:r>
             <a:endParaRPr lang="en-US" sz="1380" dirty="0"/>
           </a:p>
@@ -6852,7 +6852,7 @@
                 <a:ea typeface="Aptos" pitchFamily="34" charset="-122"/>
                 <a:cs typeface="Aptos" pitchFamily="34" charset="-120"/>
               </a:rPr>
-              <a:t>2.051.616 €</a:t>
+              <a:t>2.310.896 €</a:t>
             </a:r>
             <a:endParaRPr lang="en-US" sz="1380" dirty="0"/>
           </a:p>
@@ -7150,7 +7150,7 @@
                 <a:ea typeface="Aptos" pitchFamily="34" charset="-122"/>
                 <a:cs typeface="Aptos" pitchFamily="34" charset="-120"/>
               </a:rPr>
-              <a:t>AMR + sensores + portakits</a:t>
+              <a:t>AMR omni + sensores + portakits</a:t>
             </a:r>
             <a:endParaRPr lang="en-US" sz="580" dirty="0"/>
           </a:p>
@@ -7191,7 +7191,7 @@
                 <a:ea typeface="Aptos" pitchFamily="34" charset="-122"/>
                 <a:cs typeface="Aptos" pitchFamily="34" charset="-120"/>
               </a:rPr>
-              <a:t>69.800</a:t>
+              <a:t>78.500</a:t>
             </a:r>
             <a:endParaRPr lang="en-US" sz="580" dirty="0"/>
           </a:p>
@@ -7232,7 +7232,7 @@
                 <a:ea typeface="Aptos" pitchFamily="34" charset="-122"/>
                 <a:cs typeface="Aptos" pitchFamily="34" charset="-120"/>
               </a:rPr>
-              <a:t>488.600</a:t>
+              <a:t>549.500</a:t>
             </a:r>
             <a:endParaRPr lang="en-US" sz="580" dirty="0"/>
           </a:p>
@@ -7273,7 +7273,7 @@
                 <a:ea typeface="Aptos" pitchFamily="34" charset="-122"/>
                 <a:cs typeface="Aptos" pitchFamily="34" charset="-120"/>
               </a:rPr>
-              <a:t>1.186.600</a:t>
+              <a:t>1.334.500</a:t>
             </a:r>
             <a:endParaRPr lang="en-US" sz="580" dirty="0"/>
           </a:p>
@@ -7380,7 +7380,7 @@
                 <a:ea typeface="Aptos" pitchFamily="34" charset="-122"/>
                 <a:cs typeface="Aptos" pitchFamily="34" charset="-120"/>
               </a:rPr>
-              <a:t>22.000</a:t>
+              <a:t>24.000</a:t>
             </a:r>
             <a:endParaRPr lang="en-US" sz="580" dirty="0"/>
           </a:p>
@@ -7421,7 +7421,7 @@
                 <a:ea typeface="Aptos" pitchFamily="34" charset="-122"/>
                 <a:cs typeface="Aptos" pitchFamily="34" charset="-120"/>
               </a:rPr>
-              <a:t>58.000</a:t>
+              <a:t>65.000</a:t>
             </a:r>
             <a:endParaRPr lang="en-US" sz="580" dirty="0"/>
           </a:p>
@@ -7462,7 +7462,7 @@
                 <a:ea typeface="Aptos" pitchFamily="34" charset="-122"/>
                 <a:cs typeface="Aptos" pitchFamily="34" charset="-120"/>
               </a:rPr>
-              <a:t>105.000</a:t>
+              <a:t>120.000</a:t>
             </a:r>
             <a:endParaRPr lang="en-US" sz="580" dirty="0"/>
           </a:p>
@@ -7569,7 +7569,7 @@
                 <a:ea typeface="Aptos" pitchFamily="34" charset="-122"/>
                 <a:cs typeface="Aptos" pitchFamily="34" charset="-120"/>
               </a:rPr>
-              <a:t>42.000</a:t>
+              <a:t>46.000</a:t>
             </a:r>
             <a:endParaRPr lang="en-US" sz="580" dirty="0"/>
           </a:p>
@@ -7610,7 +7610,7 @@
                 <a:ea typeface="Aptos" pitchFamily="34" charset="-122"/>
                 <a:cs typeface="Aptos" pitchFamily="34" charset="-120"/>
               </a:rPr>
-              <a:t>112.000</a:t>
+              <a:t>126.000</a:t>
             </a:r>
             <a:endParaRPr lang="en-US" sz="580" dirty="0"/>
           </a:p>
@@ -7651,7 +7651,7 @@
                 <a:ea typeface="Aptos" pitchFamily="34" charset="-122"/>
                 <a:cs typeface="Aptos" pitchFamily="34" charset="-120"/>
               </a:rPr>
-              <a:t>215.000</a:t>
+              <a:t>245.000</a:t>
             </a:r>
             <a:endParaRPr lang="en-US" sz="580" dirty="0"/>
           </a:p>
@@ -7758,7 +7758,7 @@
                 <a:ea typeface="Aptos" pitchFamily="34" charset="-122"/>
                 <a:cs typeface="Aptos" pitchFamily="34" charset="-120"/>
               </a:rPr>
-              <a:t>18.000</a:t>
+              <a:t>20.000</a:t>
             </a:r>
             <a:endParaRPr lang="en-US" sz="580" dirty="0"/>
           </a:p>
@@ -7799,7 +7799,7 @@
                 <a:ea typeface="Aptos" pitchFamily="34" charset="-122"/>
                 <a:cs typeface="Aptos" pitchFamily="34" charset="-120"/>
               </a:rPr>
-              <a:t>52.000</a:t>
+              <a:t>60.000</a:t>
             </a:r>
             <a:endParaRPr lang="en-US" sz="580" dirty="0"/>
           </a:p>
@@ -7840,7 +7840,7 @@
                 <a:ea typeface="Aptos" pitchFamily="34" charset="-122"/>
                 <a:cs typeface="Aptos" pitchFamily="34" charset="-120"/>
               </a:rPr>
-              <a:t>120.000</a:t>
+              <a:t>135.000</a:t>
             </a:r>
             <a:endParaRPr lang="en-US" sz="580" dirty="0"/>
           </a:p>
@@ -7947,7 +7947,7 @@
                 <a:ea typeface="Aptos" pitchFamily="34" charset="-122"/>
                 <a:cs typeface="Aptos" pitchFamily="34" charset="-120"/>
               </a:rPr>
-              <a:t>8.500</a:t>
+              <a:t>9.500</a:t>
             </a:r>
             <a:endParaRPr lang="en-US" sz="580" dirty="0"/>
           </a:p>
@@ -7988,7 +7988,7 @@
                 <a:ea typeface="Aptos" pitchFamily="34" charset="-122"/>
                 <a:cs typeface="Aptos" pitchFamily="34" charset="-120"/>
               </a:rPr>
-              <a:t>24.000</a:t>
+              <a:t>27.000</a:t>
             </a:r>
             <a:endParaRPr lang="en-US" sz="580" dirty="0"/>
           </a:p>
@@ -8029,7 +8029,7 @@
                 <a:ea typeface="Aptos" pitchFamily="34" charset="-122"/>
                 <a:cs typeface="Aptos" pitchFamily="34" charset="-120"/>
               </a:rPr>
-              <a:t>42.000</a:t>
+              <a:t>46.000</a:t>
             </a:r>
             <a:endParaRPr lang="en-US" sz="580" dirty="0"/>
           </a:p>
@@ -8136,7 +8136,7 @@
                 <a:ea typeface="Aptos" pitchFamily="34" charset="-122"/>
                 <a:cs typeface="Aptos" pitchFamily="34" charset="-120"/>
               </a:rPr>
-              <a:t>5.600</a:t>
+              <a:t>6.300</a:t>
             </a:r>
             <a:endParaRPr lang="en-US" sz="580" dirty="0"/>
           </a:p>
@@ -8177,7 +8177,7 @@
                 <a:ea typeface="Aptos" pitchFamily="34" charset="-122"/>
                 <a:cs typeface="Aptos" pitchFamily="34" charset="-120"/>
               </a:rPr>
-              <a:t>39.200</a:t>
+              <a:t>44.100</a:t>
             </a:r>
             <a:endParaRPr lang="en-US" sz="580" dirty="0"/>
           </a:p>
@@ -8218,7 +8218,7 @@
                 <a:ea typeface="Aptos" pitchFamily="34" charset="-122"/>
                 <a:cs typeface="Aptos" pitchFamily="34" charset="-120"/>
               </a:rPr>
-              <a:t>95.200</a:t>
+              <a:t>106.800</a:t>
             </a:r>
             <a:endParaRPr lang="en-US" sz="580" dirty="0"/>
           </a:p>
@@ -8325,7 +8325,7 @@
                 <a:ea typeface="Aptos" pitchFamily="34" charset="-122"/>
                 <a:cs typeface="Aptos" pitchFamily="34" charset="-120"/>
               </a:rPr>
-              <a:t>11.500</a:t>
+              <a:t>12.000</a:t>
             </a:r>
             <a:endParaRPr lang="en-US" sz="580" dirty="0"/>
           </a:p>
@@ -8366,7 +8366,7 @@
                 <a:ea typeface="Aptos" pitchFamily="34" charset="-122"/>
                 <a:cs typeface="Aptos" pitchFamily="34" charset="-120"/>
               </a:rPr>
-              <a:t>34.000</a:t>
+              <a:t>38.000</a:t>
             </a:r>
             <a:endParaRPr lang="en-US" sz="580" dirty="0"/>
           </a:p>
@@ -8407,7 +8407,7 @@
                 <a:ea typeface="Aptos" pitchFamily="34" charset="-122"/>
                 <a:cs typeface="Aptos" pitchFamily="34" charset="-120"/>
               </a:rPr>
-              <a:t>68.000</a:t>
+              <a:t>76.000</a:t>
             </a:r>
             <a:endParaRPr lang="en-US" sz="580" dirty="0"/>
           </a:p>
@@ -8514,7 +8514,7 @@
                 <a:ea typeface="Aptos" pitchFamily="34" charset="-122"/>
                 <a:cs typeface="Aptos" pitchFamily="34" charset="-120"/>
               </a:rPr>
-              <a:t>21.288</a:t>
+              <a:t>23.556</a:t>
             </a:r>
             <a:endParaRPr lang="en-US" sz="580" dirty="0"/>
           </a:p>
@@ -8555,7 +8555,7 @@
                 <a:ea typeface="Aptos" pitchFamily="34" charset="-122"/>
                 <a:cs typeface="Aptos" pitchFamily="34" charset="-120"/>
               </a:rPr>
-              <a:t>96.936</a:t>
+              <a:t>109.152</a:t>
             </a:r>
             <a:endParaRPr lang="en-US" sz="580" dirty="0"/>
           </a:p>
@@ -8596,7 +8596,7 @@
                 <a:ea typeface="Aptos" pitchFamily="34" charset="-122"/>
                 <a:cs typeface="Aptos" pitchFamily="34" charset="-120"/>
               </a:rPr>
-              <a:t>219.816</a:t>
+              <a:t>247.596</a:t>
             </a:r>
             <a:endParaRPr lang="en-US" sz="580" dirty="0"/>
           </a:p>
@@ -8637,7 +8637,7 @@
                 <a:ea typeface="Aptos" pitchFamily="34" charset="-122"/>
                 <a:cs typeface="Aptos" pitchFamily="34" charset="-120"/>
               </a:rPr>
-              <a:t>Referencias publicas: MiR250, LD-250, Hokuyo, Intel RealSense y Zebra.</a:t>
+              <a:t>Referencias publicas: RB-KAIROS/AGILOX, MiR250/LD-250, Hokuyo, Intel, Zebra y SICK.</a:t>
             </a:r>
             <a:endParaRPr lang="en-US" sz="640" dirty="0"/>
           </a:p>
@@ -9557,7 +9557,7 @@
                 <a:ea typeface="Aptos" pitchFamily="34" charset="-122"/>
                 <a:cs typeface="Aptos" pitchFamily="34" charset="-120"/>
               </a:rPr>
-              <a:t>62.829 €</a:t>
+              <a:t>80.260 €</a:t>
             </a:r>
             <a:endParaRPr lang="en-US" sz="550" dirty="0"/>
           </a:p>
@@ -9679,7 +9679,7 @@
         <p:spPr>
           <a:xfrm>
             <a:off x="6812280" y="3364992"/>
-            <a:ext cx="2880360" cy="109728"/>
+            <a:ext cx="3017520" cy="109728"/>
           </a:xfrm>
           <a:prstGeom prst="rect">
             <a:avLst/>
@@ -9744,7 +9744,7 @@
         </p:nvSpPr>
         <p:spPr>
           <a:xfrm>
-            <a:off x="9738360" y="3319272"/>
+            <a:off x="9875520" y="3319272"/>
             <a:ext cx="868680" cy="146304"/>
           </a:xfrm>
           <a:prstGeom prst="rect">
@@ -9771,7 +9771,7 @@
                 <a:ea typeface="Aptos" pitchFamily="34" charset="-122"/>
                 <a:cs typeface="Aptos" pitchFamily="34" charset="-120"/>
               </a:rPr>
-              <a:t>316.429 €</a:t>
+              <a:t>359.263 €</a:t>
             </a:r>
             <a:endParaRPr lang="en-US" sz="550" dirty="0"/>
           </a:p>
@@ -9893,7 +9893,7 @@
         <p:spPr>
           <a:xfrm>
             <a:off x="6812280" y="4325112"/>
-            <a:ext cx="4160520" cy="109728"/>
+            <a:ext cx="4389120" cy="109728"/>
           </a:xfrm>
           <a:prstGeom prst="rect">
             <a:avLst/>
@@ -9958,7 +9958,7 @@
         </p:nvSpPr>
         <p:spPr>
           <a:xfrm>
-            <a:off x="11018520" y="4279392"/>
+            <a:off x="11247120" y="4279392"/>
             <a:ext cx="868680" cy="146304"/>
           </a:xfrm>
           <a:prstGeom prst="rect">
@@ -9985,7 +9985,7 @@
                 <a:ea typeface="Aptos" pitchFamily="34" charset="-122"/>
                 <a:cs typeface="Aptos" pitchFamily="34" charset="-120"/>
               </a:rPr>
-              <a:t>714.125 €</a:t>
+              <a:t>814.017 €</a:t>
             </a:r>
             <a:endParaRPr lang="en-US" sz="550" dirty="0"/>
           </a:p>
@@ -17406,7 +17406,7 @@
                 <a:ea typeface="Aptos Display" pitchFamily="34" charset="-122"/>
                 <a:cs typeface="Aptos Display" pitchFamily="34" charset="-120"/>
               </a:rPr>
-              <a:t>Por que AMR omnidireccional</a:t>
+              <a:t>Matriz de decisión, no seleccion por intuicion</a:t>
             </a:r>
             <a:endParaRPr lang="en-US" sz="2000" dirty="0"/>
           </a:p>
@@ -17537,36 +17537,36 @@
         </p:nvSpPr>
         <p:spPr>
           <a:xfrm>
-            <a:off x="822960" y="1234440"/>
-            <a:ext cx="2926080" cy="320040"/>
-          </a:xfrm>
-          <a:prstGeom prst="rect">
-            <a:avLst/>
-          </a:prstGeom>
-          <a:noFill/>
-          <a:ln/>
-        </p:spPr>
-        <p:txBody>
-          <a:bodyPr wrap="square" lIns="381" tIns="381" rIns="381" bIns="381" rtlCol="0" anchor="ctr">
-            <a:normAutofit/>
-          </a:bodyPr>
-          <a:lstStyle/>
-          <a:p>
-            <a:pPr algn="l" indent="0" marL="0">
-              <a:buNone/>
-            </a:pPr>
-            <a:r>
-              <a:rPr lang="en-US" sz="1900" b="1" dirty="0">
-                <a:solidFill>
-                  <a:srgbClr val="1F7A8C"/>
-                </a:solidFill>
-                <a:latin typeface="Aptos" pitchFamily="34" charset="0"/>
-                <a:ea typeface="Aptos" pitchFamily="34" charset="-122"/>
-                <a:cs typeface="Aptos" pitchFamily="34" charset="-120"/>
-              </a:rPr>
-              <a:t>Seleccionado</a:t>
-            </a:r>
-            <a:endParaRPr lang="en-US" sz="1900" dirty="0"/>
+            <a:off x="777240" y="1005840"/>
+            <a:ext cx="2468880" cy="155448"/>
+          </a:xfrm>
+          <a:prstGeom prst="rect">
+            <a:avLst/>
+          </a:prstGeom>
+          <a:noFill/>
+          <a:ln/>
+        </p:spPr>
+        <p:txBody>
+          <a:bodyPr wrap="square" lIns="381" tIns="381" rIns="381" bIns="381" rtlCol="0" anchor="ctr">
+            <a:normAutofit/>
+          </a:bodyPr>
+          <a:lstStyle/>
+          <a:p>
+            <a:pPr algn="l" indent="0" marL="0">
+              <a:buNone/>
+            </a:pPr>
+            <a:r>
+              <a:rPr lang="en-US" sz="650" b="1" dirty="0">
+                <a:solidFill>
+                  <a:srgbClr val="5D6B7A"/>
+                </a:solidFill>
+                <a:latin typeface="Aptos" pitchFamily="34" charset="0"/>
+                <a:ea typeface="Aptos" pitchFamily="34" charset="-122"/>
+                <a:cs typeface="Aptos" pitchFamily="34" charset="-120"/>
+              </a:rPr>
+              <a:t>PUNTUACION PONDERADA SOBRE 5</a:t>
+            </a:r>
+            <a:endParaRPr lang="en-US" sz="650" dirty="0"/>
           </a:p>
         </p:txBody>
       </p:sp>
@@ -17578,26 +17578,67 @@
         </p:nvSpPr>
         <p:spPr>
           <a:xfrm>
-            <a:off x="841248" y="1700784"/>
-            <a:ext cx="3200400" cy="347472"/>
-          </a:xfrm>
-          <a:prstGeom prst="rect">
-            <a:avLst/>
-          </a:prstGeom>
-          <a:noFill/>
-          <a:ln/>
-        </p:spPr>
-        <p:txBody>
-          <a:bodyPr wrap="square" lIns="381" tIns="381" rIns="381" bIns="381" rtlCol="0" anchor="ctr">
-            <a:normAutofit/>
-          </a:bodyPr>
-          <a:lstStyle/>
-          <a:p>
-            <a:pPr algn="l" indent="0" marL="0">
-              <a:buNone/>
-            </a:pPr>
-            <a:r>
-              <a:rPr lang="en-US" sz="840" b="1" dirty="0">
+            <a:off x="777240" y="1298448"/>
+            <a:ext cx="1143000" cy="329184"/>
+          </a:xfrm>
+          <a:prstGeom prst="rect">
+            <a:avLst/>
+          </a:prstGeom>
+          <a:noFill/>
+          <a:ln/>
+        </p:spPr>
+        <p:txBody>
+          <a:bodyPr wrap="square" lIns="381" tIns="381" rIns="381" bIns="381" rtlCol="0" anchor="ctr">
+            <a:normAutofit/>
+          </a:bodyPr>
+          <a:lstStyle/>
+          <a:p>
+            <a:pPr algn="l" indent="0" marL="0">
+              <a:buNone/>
+            </a:pPr>
+            <a:r>
+              <a:rPr lang="en-US" sz="2300" b="1" dirty="0">
+                <a:solidFill>
+                  <a:srgbClr val="2A9D8F"/>
+                </a:solidFill>
+                <a:latin typeface="Aptos" pitchFamily="34" charset="0"/>
+                <a:ea typeface="Aptos" pitchFamily="34" charset="-122"/>
+                <a:cs typeface="Aptos" pitchFamily="34" charset="-120"/>
+              </a:rPr>
+              <a:t>4,25</a:t>
+            </a:r>
+            <a:endParaRPr lang="en-US" sz="2300" dirty="0"/>
+          </a:p>
+        </p:txBody>
+      </p:sp>
+      <p:sp>
+        <p:nvSpPr>
+          <p:cNvPr id="10" name="Text 8"/>
+          <p:cNvSpPr/>
+          <p:nvPr/>
+        </p:nvSpPr>
+        <p:spPr>
+          <a:xfrm>
+            <a:off x="2331720" y="1261872"/>
+            <a:ext cx="3383280" cy="457200"/>
+          </a:xfrm>
+          <a:prstGeom prst="rect">
+            <a:avLst/>
+          </a:prstGeom>
+          <a:noFill/>
+          <a:ln/>
+        </p:spPr>
+        <p:txBody>
+          <a:bodyPr wrap="square" lIns="381" tIns="381" rIns="381" bIns="381" rtlCol="0" anchor="ctr">
+            <a:normAutofit/>
+          </a:bodyPr>
+          <a:lstStyle/>
+          <a:p>
+            <a:pPr algn="l" indent="0" marL="0">
+              <a:buNone/>
+            </a:pPr>
+            <a:r>
+              <a:rPr lang="en-US" sz="870" b="1" dirty="0">
                 <a:solidFill>
                   <a:srgbClr val="102033"/>
                 </a:solidFill>
@@ -17605,34 +17646,131 @@
                 <a:ea typeface="Aptos" pitchFamily="34" charset="-122"/>
                 <a:cs typeface="Aptos" pitchFamily="34" charset="-120"/>
               </a:rPr>
-              <a:t>AMR omnidireccional representable en CoppeliaSim</a:t>
-            </a:r>
-            <a:endParaRPr lang="en-US" sz="840" dirty="0"/>
-          </a:p>
-        </p:txBody>
-      </p:sp>
-      <p:sp>
-        <p:nvSpPr>
-          <p:cNvPr id="10" name="Shape 8"/>
-          <p:cNvSpPr/>
-          <p:nvPr/>
-        </p:nvSpPr>
-        <p:spPr>
-          <a:xfrm>
-            <a:off x="1261872" y="2606040"/>
-            <a:ext cx="1623060" cy="1051560"/>
-          </a:xfrm>
-          <a:prstGeom prst="roundRect">
-            <a:avLst>
-              <a:gd name="adj" fmla="val 6957"/>
-            </a:avLst>
+              <a:t>AMR omnidireccional</a:t>
+            </a:r>
+            <a:endParaRPr lang="en-US" sz="870" dirty="0"/>
+          </a:p>
+          <a:p>
+            <a:pPr algn="l" indent="0" marL="0">
+              <a:buNone/>
+            </a:pPr>
+            <a:r>
+              <a:rPr lang="en-US" sz="870" b="1" dirty="0">
+                <a:solidFill>
+                  <a:srgbClr val="102033"/>
+                </a:solidFill>
+                <a:latin typeface="Aptos" pitchFamily="34" charset="0"/>
+                <a:ea typeface="Aptos" pitchFamily="34" charset="-122"/>
+                <a:cs typeface="Aptos" pitchFamily="34" charset="-120"/>
+              </a:rPr>
+              <a:t>RB-KAIROS/AGILOX-class</a:t>
+            </a:r>
+            <a:endParaRPr lang="en-US" sz="870" dirty="0"/>
+          </a:p>
+        </p:txBody>
+      </p:sp>
+      <p:sp>
+        <p:nvSpPr>
+          <p:cNvPr id="11" name="Text 9"/>
+          <p:cNvSpPr/>
+          <p:nvPr/>
+        </p:nvSpPr>
+        <p:spPr>
+          <a:xfrm>
+            <a:off x="804672" y="1901952"/>
+            <a:ext cx="4663440" cy="384048"/>
+          </a:xfrm>
+          <a:prstGeom prst="rect">
+            <a:avLst/>
+          </a:prstGeom>
+          <a:noFill/>
+          <a:ln/>
+        </p:spPr>
+        <p:txBody>
+          <a:bodyPr wrap="square" lIns="381" tIns="381" rIns="381" bIns="381" rtlCol="0" anchor="ctr">
+            <a:normAutofit/>
+          </a:bodyPr>
+          <a:lstStyle/>
+          <a:p>
+            <a:pPr algn="l" indent="0" marL="0">
+              <a:buNone/>
+            </a:pPr>
+            <a:r>
+              <a:rPr lang="en-US" sz="640" dirty="0">
+                <a:solidFill>
+                  <a:srgbClr val="5D6B7A"/>
+                </a:solidFill>
+                <a:latin typeface="Aptos" pitchFamily="34" charset="0"/>
+                <a:ea typeface="Aptos" pitchFamily="34" charset="-122"/>
+                <a:cs typeface="Aptos" pitchFamily="34" charset="-120"/>
+              </a:rPr>
+              <a:t>Gana por maniobra en estación y representabilidad en CoppeliaSim; no por ser la opcion mas barata.</a:t>
+            </a:r>
+            <a:endParaRPr lang="en-US" sz="640" dirty="0"/>
+          </a:p>
+        </p:txBody>
+      </p:sp>
+      <p:sp>
+        <p:nvSpPr>
+          <p:cNvPr id="12" name="Text 10"/>
+          <p:cNvSpPr/>
+          <p:nvPr/>
+        </p:nvSpPr>
+        <p:spPr>
+          <a:xfrm>
+            <a:off x="822960" y="2633472"/>
+            <a:ext cx="2331720" cy="164592"/>
+          </a:xfrm>
+          <a:prstGeom prst="rect">
+            <a:avLst/>
+          </a:prstGeom>
+          <a:noFill/>
+          <a:ln/>
+        </p:spPr>
+        <p:txBody>
+          <a:bodyPr wrap="square" lIns="381" tIns="381" rIns="381" bIns="381" rtlCol="0" anchor="ctr">
+            <a:normAutofit/>
+          </a:bodyPr>
+          <a:lstStyle/>
+          <a:p>
+            <a:pPr algn="l" indent="0" marL="0">
+              <a:buNone/>
+            </a:pPr>
+            <a:r>
+              <a:rPr lang="en-US" sz="660" b="1" dirty="0">
+                <a:solidFill>
+                  <a:srgbClr val="1B2430"/>
+                </a:solidFill>
+                <a:latin typeface="Aptos" pitchFamily="34" charset="0"/>
+                <a:ea typeface="Aptos" pitchFamily="34" charset="-122"/>
+                <a:cs typeface="Aptos" pitchFamily="34" charset="-120"/>
+              </a:rPr>
+              <a:t>AMR omnidireccional</a:t>
+            </a:r>
+            <a:endParaRPr lang="en-US" sz="660" dirty="0"/>
+          </a:p>
+        </p:txBody>
+      </p:sp>
+      <p:sp>
+        <p:nvSpPr>
+          <p:cNvPr id="13" name="Shape 11"/>
+          <p:cNvSpPr/>
+          <p:nvPr/>
+        </p:nvSpPr>
+        <p:spPr>
+          <a:xfrm>
+            <a:off x="3493008" y="2670048"/>
+            <a:ext cx="3749040" cy="128016"/>
+          </a:xfrm>
+          <a:prstGeom prst="rect">
+            <a:avLst/>
           </a:prstGeom>
           <a:solidFill>
-            <a:srgbClr val="E9F5FA"/>
+            <a:srgbClr val="E8EEF4"/>
           </a:solidFill>
           <a:ln w="12700">
             <a:solidFill>
-              <a:srgbClr val="102033"/>
+              <a:srgbClr val="E8EEF4"/>
             </a:solidFill>
             <a:prstDash val="solid"/>
           </a:ln>
@@ -17640,24 +17778,24 @@
       </p:sp>
       <p:sp>
         <p:nvSpPr>
-          <p:cNvPr id="11" name="Shape 9"/>
-          <p:cNvSpPr/>
-          <p:nvPr/>
-        </p:nvSpPr>
-        <p:spPr>
-          <a:xfrm>
-            <a:off x="1399032" y="2754630"/>
-            <a:ext cx="160020" cy="754380"/>
+          <p:cNvPr id="14" name="Shape 12"/>
+          <p:cNvSpPr/>
+          <p:nvPr/>
+        </p:nvSpPr>
+        <p:spPr>
+          <a:xfrm>
+            <a:off x="3493008" y="2670048"/>
+            <a:ext cx="3520440" cy="128016"/>
           </a:xfrm>
           <a:prstGeom prst="rect">
             <a:avLst/>
           </a:prstGeom>
           <a:solidFill>
-            <a:srgbClr val="1B2430"/>
+            <a:srgbClr val="2A9D8F"/>
           </a:solidFill>
           <a:ln w="12700">
             <a:solidFill>
-              <a:srgbClr val="1B2430"/>
+              <a:srgbClr val="2A9D8F"/>
             </a:solidFill>
             <a:prstDash val="solid"/>
           </a:ln>
@@ -17665,24 +17803,106 @@
       </p:sp>
       <p:sp>
         <p:nvSpPr>
-          <p:cNvPr id="12" name="Shape 10"/>
-          <p:cNvSpPr/>
-          <p:nvPr/>
-        </p:nvSpPr>
-        <p:spPr>
-          <a:xfrm>
-            <a:off x="2587752" y="2754630"/>
-            <a:ext cx="160020" cy="754380"/>
+          <p:cNvPr id="15" name="Text 13"/>
+          <p:cNvSpPr/>
+          <p:nvPr/>
+        </p:nvSpPr>
+        <p:spPr>
+          <a:xfrm>
+            <a:off x="7452360" y="2624328"/>
+            <a:ext cx="384048" cy="164592"/>
+          </a:xfrm>
+          <a:prstGeom prst="rect">
+            <a:avLst/>
+          </a:prstGeom>
+          <a:noFill/>
+          <a:ln/>
+        </p:spPr>
+        <p:txBody>
+          <a:bodyPr wrap="square" lIns="381" tIns="381" rIns="381" bIns="381" rtlCol="0" anchor="ctr">
+            <a:normAutofit/>
+          </a:bodyPr>
+          <a:lstStyle/>
+          <a:p>
+            <a:pPr algn="l" indent="0" marL="0">
+              <a:buNone/>
+            </a:pPr>
+            <a:r>
+              <a:rPr lang="en-US" sz="660" b="1" dirty="0">
+                <a:solidFill>
+                  <a:srgbClr val="2A9D8F"/>
+                </a:solidFill>
+                <a:latin typeface="Aptos" pitchFamily="34" charset="0"/>
+                <a:ea typeface="Aptos" pitchFamily="34" charset="-122"/>
+                <a:cs typeface="Aptos" pitchFamily="34" charset="-120"/>
+              </a:rPr>
+              <a:t>4,25</a:t>
+            </a:r>
+            <a:endParaRPr lang="en-US" sz="660" dirty="0"/>
+          </a:p>
+        </p:txBody>
+      </p:sp>
+      <p:sp>
+        <p:nvSpPr>
+          <p:cNvPr id="16" name="Text 14"/>
+          <p:cNvSpPr/>
+          <p:nvPr/>
+        </p:nvSpPr>
+        <p:spPr>
+          <a:xfrm>
+            <a:off x="822960" y="3054096"/>
+            <a:ext cx="2331720" cy="164592"/>
+          </a:xfrm>
+          <a:prstGeom prst="rect">
+            <a:avLst/>
+          </a:prstGeom>
+          <a:noFill/>
+          <a:ln/>
+        </p:spPr>
+        <p:txBody>
+          <a:bodyPr wrap="square" lIns="381" tIns="381" rIns="381" bIns="381" rtlCol="0" anchor="ctr">
+            <a:normAutofit/>
+          </a:bodyPr>
+          <a:lstStyle/>
+          <a:p>
+            <a:pPr algn="l" indent="0" marL="0">
+              <a:buNone/>
+            </a:pPr>
+            <a:r>
+              <a:rPr lang="en-US" sz="660" b="1" dirty="0">
+                <a:solidFill>
+                  <a:srgbClr val="1B2430"/>
+                </a:solidFill>
+                <a:latin typeface="Aptos" pitchFamily="34" charset="0"/>
+                <a:ea typeface="Aptos" pitchFamily="34" charset="-122"/>
+                <a:cs typeface="Aptos" pitchFamily="34" charset="-120"/>
+              </a:rPr>
+              <a:t>AMR diferencial MiR/Omron</a:t>
+            </a:r>
+            <a:endParaRPr lang="en-US" sz="660" dirty="0"/>
+          </a:p>
+        </p:txBody>
+      </p:sp>
+      <p:sp>
+        <p:nvSpPr>
+          <p:cNvPr id="17" name="Shape 15"/>
+          <p:cNvSpPr/>
+          <p:nvPr/>
+        </p:nvSpPr>
+        <p:spPr>
+          <a:xfrm>
+            <a:off x="3493008" y="3090672"/>
+            <a:ext cx="3749040" cy="128016"/>
           </a:xfrm>
           <a:prstGeom prst="rect">
             <a:avLst/>
           </a:prstGeom>
           <a:solidFill>
-            <a:srgbClr val="1B2430"/>
+            <a:srgbClr val="E8EEF4"/>
           </a:solidFill>
           <a:ln w="12700">
             <a:solidFill>
-              <a:srgbClr val="1B2430"/>
+              <a:srgbClr val="E8EEF4"/>
             </a:solidFill>
             <a:prstDash val="solid"/>
           </a:ln>
@@ -17690,105 +17910,14 @@
       </p:sp>
       <p:sp>
         <p:nvSpPr>
-          <p:cNvPr id="13" name="Shape 11"/>
-          <p:cNvSpPr/>
-          <p:nvPr/>
-        </p:nvSpPr>
-        <p:spPr>
-          <a:xfrm>
-            <a:off x="1810512" y="2857500"/>
-            <a:ext cx="548640" cy="548640"/>
-          </a:xfrm>
-          <a:prstGeom prst="ellipse">
-            <a:avLst/>
-          </a:prstGeom>
-          <a:solidFill>
-            <a:srgbClr val="BDEAF6"/>
-          </a:solidFill>
-          <a:ln w="13970">
-            <a:solidFill>
-              <a:srgbClr val="2DB7E5"/>
-            </a:solidFill>
-            <a:prstDash val="solid"/>
-          </a:ln>
-        </p:spPr>
-      </p:sp>
-      <p:sp>
-        <p:nvSpPr>
-          <p:cNvPr id="14" name="Shape 12"/>
-          <p:cNvSpPr/>
-          <p:nvPr/>
-        </p:nvSpPr>
-        <p:spPr>
-          <a:xfrm>
-            <a:off x="1981962" y="3028950"/>
-            <a:ext cx="205740" cy="205740"/>
-          </a:xfrm>
-          <a:prstGeom prst="ellipse">
-            <a:avLst/>
-          </a:prstGeom>
-          <a:solidFill>
-            <a:srgbClr val="2DB7E5"/>
-          </a:solidFill>
-          <a:ln w="12700">
-            <a:solidFill>
-              <a:srgbClr val="2DB7E5"/>
-            </a:solidFill>
-            <a:prstDash val="solid"/>
-          </a:ln>
-        </p:spPr>
-      </p:sp>
-      <p:sp>
-        <p:nvSpPr>
-          <p:cNvPr id="15" name="Text 13"/>
-          <p:cNvSpPr/>
-          <p:nvPr/>
-        </p:nvSpPr>
-        <p:spPr>
-          <a:xfrm>
-            <a:off x="841248" y="4069080"/>
-            <a:ext cx="3291840" cy="502920"/>
-          </a:xfrm>
-          <a:prstGeom prst="rect">
-            <a:avLst/>
-          </a:prstGeom>
-          <a:noFill/>
-          <a:ln/>
-        </p:spPr>
-        <p:txBody>
-          <a:bodyPr wrap="square" lIns="381" tIns="381" rIns="381" bIns="381" rtlCol="0" anchor="ctr">
-            <a:normAutofit/>
-          </a:bodyPr>
-          <a:lstStyle/>
-          <a:p>
-            <a:pPr algn="l" indent="0" marL="0">
-              <a:buNone/>
-            </a:pPr>
-            <a:r>
-              <a:rPr lang="en-US" sz="760" dirty="0">
-                <a:solidFill>
-                  <a:srgbClr val="5D6B7A"/>
-                </a:solidFill>
-                <a:latin typeface="Aptos" pitchFamily="34" charset="0"/>
-                <a:ea typeface="Aptos" pitchFamily="34" charset="-122"/>
-                <a:cs typeface="Aptos" pitchFamily="34" charset="-120"/>
-              </a:rPr>
-              <a:t>Movimiento lateral sin reorientar carga; mejor cerca de útiles, estaciones y operarios.</a:t>
-            </a:r>
-            <a:endParaRPr lang="en-US" sz="760" dirty="0"/>
-          </a:p>
-        </p:txBody>
-      </p:sp>
-      <p:sp>
-        <p:nvSpPr>
-          <p:cNvPr id="16" name="Shape 14"/>
-          <p:cNvSpPr/>
-          <p:nvPr/>
-        </p:nvSpPr>
-        <p:spPr>
-          <a:xfrm>
-            <a:off x="5669280" y="1417320"/>
-            <a:ext cx="109728" cy="109728"/>
+          <p:cNvPr id="18" name="Shape 16"/>
+          <p:cNvSpPr/>
+          <p:nvPr/>
+        </p:nvSpPr>
+        <p:spPr>
+          <a:xfrm>
+            <a:off x="3493008" y="3090672"/>
+            <a:ext cx="3200400" cy="128016"/>
           </a:xfrm>
           <a:prstGeom prst="rect">
             <a:avLst/>
@@ -17806,32 +17935,73 @@
       </p:sp>
       <p:sp>
         <p:nvSpPr>
-          <p:cNvPr id="17" name="Text 15"/>
-          <p:cNvSpPr/>
-          <p:nvPr/>
-        </p:nvSpPr>
-        <p:spPr>
-          <a:xfrm>
-            <a:off x="5925312" y="1298448"/>
-            <a:ext cx="4480560" cy="329184"/>
-          </a:xfrm>
-          <a:prstGeom prst="rect">
-            <a:avLst/>
-          </a:prstGeom>
-          <a:noFill/>
-          <a:ln/>
-        </p:spPr>
-        <p:txBody>
-          <a:bodyPr wrap="square" lIns="381" tIns="381" rIns="381" bIns="381" rtlCol="0" anchor="ctr">
-            <a:normAutofit/>
-          </a:bodyPr>
-          <a:lstStyle/>
-          <a:p>
-            <a:pPr algn="l" indent="0" marL="0">
-              <a:buNone/>
-            </a:pPr>
-            <a:r>
-              <a:rPr lang="en-US" sz="820" dirty="0">
+          <p:cNvPr id="19" name="Text 17"/>
+          <p:cNvSpPr/>
+          <p:nvPr/>
+        </p:nvSpPr>
+        <p:spPr>
+          <a:xfrm>
+            <a:off x="7452360" y="3044952"/>
+            <a:ext cx="384048" cy="164592"/>
+          </a:xfrm>
+          <a:prstGeom prst="rect">
+            <a:avLst/>
+          </a:prstGeom>
+          <a:noFill/>
+          <a:ln/>
+        </p:spPr>
+        <p:txBody>
+          <a:bodyPr wrap="square" lIns="381" tIns="381" rIns="381" bIns="381" rtlCol="0" anchor="ctr">
+            <a:normAutofit/>
+          </a:bodyPr>
+          <a:lstStyle/>
+          <a:p>
+            <a:pPr algn="l" indent="0" marL="0">
+              <a:buNone/>
+            </a:pPr>
+            <a:r>
+              <a:rPr lang="en-US" sz="660" b="1" dirty="0">
+                <a:solidFill>
+                  <a:srgbClr val="1F7A8C"/>
+                </a:solidFill>
+                <a:latin typeface="Aptos" pitchFamily="34" charset="0"/>
+                <a:ea typeface="Aptos" pitchFamily="34" charset="-122"/>
+                <a:cs typeface="Aptos" pitchFamily="34" charset="-120"/>
+              </a:rPr>
+              <a:t>3,85</a:t>
+            </a:r>
+            <a:endParaRPr lang="en-US" sz="660" dirty="0"/>
+          </a:p>
+        </p:txBody>
+      </p:sp>
+      <p:sp>
+        <p:nvSpPr>
+          <p:cNvPr id="20" name="Text 18"/>
+          <p:cNvSpPr/>
+          <p:nvPr/>
+        </p:nvSpPr>
+        <p:spPr>
+          <a:xfrm>
+            <a:off x="822960" y="3474720"/>
+            <a:ext cx="2331720" cy="164592"/>
+          </a:xfrm>
+          <a:prstGeom prst="rect">
+            <a:avLst/>
+          </a:prstGeom>
+          <a:noFill/>
+          <a:ln/>
+        </p:spPr>
+        <p:txBody>
+          <a:bodyPr wrap="square" lIns="381" tIns="381" rIns="381" bIns="381" rtlCol="0" anchor="ctr">
+            <a:normAutofit/>
+          </a:bodyPr>
+          <a:lstStyle/>
+          <a:p>
+            <a:pPr algn="l" indent="0" marL="0">
+              <a:buNone/>
+            </a:pPr>
+            <a:r>
+              <a:rPr lang="en-US" sz="660" b="1" dirty="0">
                 <a:solidFill>
                   <a:srgbClr val="1B2430"/>
                 </a:solidFill>
@@ -17839,22 +18009,47 @@
                 <a:ea typeface="Aptos" pitchFamily="34" charset="-122"/>
                 <a:cs typeface="Aptos" pitchFamily="34" charset="-120"/>
               </a:rPr>
-              <a:t>AGV: fiable, pero rigido si cambian rutas.</a:t>
-            </a:r>
-            <a:endParaRPr lang="en-US" sz="820" dirty="0"/>
-          </a:p>
-        </p:txBody>
-      </p:sp>
-      <p:sp>
-        <p:nvSpPr>
-          <p:cNvPr id="18" name="Shape 16"/>
-          <p:cNvSpPr/>
-          <p:nvPr/>
-        </p:nvSpPr>
-        <p:spPr>
-          <a:xfrm>
-            <a:off x="5669280" y="2075688"/>
-            <a:ext cx="109728" cy="109728"/>
+              <a:t>AGV</a:t>
+            </a:r>
+            <a:endParaRPr lang="en-US" sz="660" dirty="0"/>
+          </a:p>
+        </p:txBody>
+      </p:sp>
+      <p:sp>
+        <p:nvSpPr>
+          <p:cNvPr id="21" name="Shape 19"/>
+          <p:cNvSpPr/>
+          <p:nvPr/>
+        </p:nvSpPr>
+        <p:spPr>
+          <a:xfrm>
+            <a:off x="3493008" y="3511296"/>
+            <a:ext cx="3749040" cy="128016"/>
+          </a:xfrm>
+          <a:prstGeom prst="rect">
+            <a:avLst/>
+          </a:prstGeom>
+          <a:solidFill>
+            <a:srgbClr val="E8EEF4"/>
+          </a:solidFill>
+          <a:ln w="12700">
+            <a:solidFill>
+              <a:srgbClr val="E8EEF4"/>
+            </a:solidFill>
+            <a:prstDash val="solid"/>
+          </a:ln>
+        </p:spPr>
+      </p:sp>
+      <p:sp>
+        <p:nvSpPr>
+          <p:cNvPr id="22" name="Shape 20"/>
+          <p:cNvSpPr/>
+          <p:nvPr/>
+        </p:nvSpPr>
+        <p:spPr>
+          <a:xfrm>
+            <a:off x="3493008" y="3511296"/>
+            <a:ext cx="2542032" cy="128016"/>
           </a:xfrm>
           <a:prstGeom prst="rect">
             <a:avLst/>
@@ -17872,32 +18067,73 @@
       </p:sp>
       <p:sp>
         <p:nvSpPr>
-          <p:cNvPr id="19" name="Text 17"/>
-          <p:cNvSpPr/>
-          <p:nvPr/>
-        </p:nvSpPr>
-        <p:spPr>
-          <a:xfrm>
-            <a:off x="5925312" y="1956816"/>
-            <a:ext cx="4480560" cy="329184"/>
-          </a:xfrm>
-          <a:prstGeom prst="rect">
-            <a:avLst/>
-          </a:prstGeom>
-          <a:noFill/>
-          <a:ln/>
-        </p:spPr>
-        <p:txBody>
-          <a:bodyPr wrap="square" lIns="381" tIns="381" rIns="381" bIns="381" rtlCol="0" anchor="ctr">
-            <a:normAutofit/>
-          </a:bodyPr>
-          <a:lstStyle/>
-          <a:p>
-            <a:pPr algn="l" indent="0" marL="0">
-              <a:buNone/>
-            </a:pPr>
-            <a:r>
-              <a:rPr lang="en-US" sz="820" dirty="0">
+          <p:cNvPr id="23" name="Text 21"/>
+          <p:cNvSpPr/>
+          <p:nvPr/>
+        </p:nvSpPr>
+        <p:spPr>
+          <a:xfrm>
+            <a:off x="7452360" y="3465576"/>
+            <a:ext cx="384048" cy="164592"/>
+          </a:xfrm>
+          <a:prstGeom prst="rect">
+            <a:avLst/>
+          </a:prstGeom>
+          <a:noFill/>
+          <a:ln/>
+        </p:spPr>
+        <p:txBody>
+          <a:bodyPr wrap="square" lIns="381" tIns="381" rIns="381" bIns="381" rtlCol="0" anchor="ctr">
+            <a:normAutofit/>
+          </a:bodyPr>
+          <a:lstStyle/>
+          <a:p>
+            <a:pPr algn="l" indent="0" marL="0">
+              <a:buNone/>
+            </a:pPr>
+            <a:r>
+              <a:rPr lang="en-US" sz="660" b="1" dirty="0">
+                <a:solidFill>
+                  <a:srgbClr val="F4A261"/>
+                </a:solidFill>
+                <a:latin typeface="Aptos" pitchFamily="34" charset="0"/>
+                <a:ea typeface="Aptos" pitchFamily="34" charset="-122"/>
+                <a:cs typeface="Aptos" pitchFamily="34" charset="-120"/>
+              </a:rPr>
+              <a:t>3,05</a:t>
+            </a:r>
+            <a:endParaRPr lang="en-US" sz="660" dirty="0"/>
+          </a:p>
+        </p:txBody>
+      </p:sp>
+      <p:sp>
+        <p:nvSpPr>
+          <p:cNvPr id="24" name="Text 22"/>
+          <p:cNvSpPr/>
+          <p:nvPr/>
+        </p:nvSpPr>
+        <p:spPr>
+          <a:xfrm>
+            <a:off x="822960" y="3895344"/>
+            <a:ext cx="2331720" cy="164592"/>
+          </a:xfrm>
+          <a:prstGeom prst="rect">
+            <a:avLst/>
+          </a:prstGeom>
+          <a:noFill/>
+          <a:ln/>
+        </p:spPr>
+        <p:txBody>
+          <a:bodyPr wrap="square" lIns="381" tIns="381" rIns="381" bIns="381" rtlCol="0" anchor="ctr">
+            <a:normAutofit/>
+          </a:bodyPr>
+          <a:lstStyle/>
+          <a:p>
+            <a:pPr algn="l" indent="0" marL="0">
+              <a:buNone/>
+            </a:pPr>
+            <a:r>
+              <a:rPr lang="en-US" sz="660" b="1" dirty="0">
                 <a:solidFill>
                   <a:srgbClr val="1B2430"/>
                 </a:solidFill>
@@ -17905,22 +18141,179 @@
                 <a:ea typeface="Aptos" pitchFamily="34" charset="-122"/>
                 <a:cs typeface="Aptos" pitchFamily="34" charset="-120"/>
               </a:rPr>
-              <a:t>Dron: baja carga y riesgo en interior industrial.</a:t>
-            </a:r>
-            <a:endParaRPr lang="en-US" sz="820" dirty="0"/>
-          </a:p>
-        </p:txBody>
-      </p:sp>
-      <p:sp>
-        <p:nvSpPr>
-          <p:cNvPr id="20" name="Shape 18"/>
-          <p:cNvSpPr/>
-          <p:nvPr/>
-        </p:nvSpPr>
-        <p:spPr>
-          <a:xfrm>
-            <a:off x="5669280" y="2734056"/>
-            <a:ext cx="109728" cy="109728"/>
+              <a:t>robot con patas</a:t>
+            </a:r>
+            <a:endParaRPr lang="en-US" sz="660" dirty="0"/>
+          </a:p>
+        </p:txBody>
+      </p:sp>
+      <p:sp>
+        <p:nvSpPr>
+          <p:cNvPr id="25" name="Shape 23"/>
+          <p:cNvSpPr/>
+          <p:nvPr/>
+        </p:nvSpPr>
+        <p:spPr>
+          <a:xfrm>
+            <a:off x="3493008" y="3931920"/>
+            <a:ext cx="3749040" cy="128016"/>
+          </a:xfrm>
+          <a:prstGeom prst="rect">
+            <a:avLst/>
+          </a:prstGeom>
+          <a:solidFill>
+            <a:srgbClr val="E8EEF4"/>
+          </a:solidFill>
+          <a:ln w="12700">
+            <a:solidFill>
+              <a:srgbClr val="E8EEF4"/>
+            </a:solidFill>
+            <a:prstDash val="solid"/>
+          </a:ln>
+        </p:spPr>
+      </p:sp>
+      <p:sp>
+        <p:nvSpPr>
+          <p:cNvPr id="26" name="Shape 24"/>
+          <p:cNvSpPr/>
+          <p:nvPr/>
+        </p:nvSpPr>
+        <p:spPr>
+          <a:xfrm>
+            <a:off x="3493008" y="3931920"/>
+            <a:ext cx="1517904" cy="128016"/>
+          </a:xfrm>
+          <a:prstGeom prst="rect">
+            <a:avLst/>
+          </a:prstGeom>
+          <a:solidFill>
+            <a:srgbClr val="6D5BD0"/>
+          </a:solidFill>
+          <a:ln w="12700">
+            <a:solidFill>
+              <a:srgbClr val="6D5BD0"/>
+            </a:solidFill>
+            <a:prstDash val="solid"/>
+          </a:ln>
+        </p:spPr>
+      </p:sp>
+      <p:sp>
+        <p:nvSpPr>
+          <p:cNvPr id="27" name="Text 25"/>
+          <p:cNvSpPr/>
+          <p:nvPr/>
+        </p:nvSpPr>
+        <p:spPr>
+          <a:xfrm>
+            <a:off x="7452360" y="3886200"/>
+            <a:ext cx="384048" cy="164592"/>
+          </a:xfrm>
+          <a:prstGeom prst="rect">
+            <a:avLst/>
+          </a:prstGeom>
+          <a:noFill/>
+          <a:ln/>
+        </p:spPr>
+        <p:txBody>
+          <a:bodyPr wrap="square" lIns="381" tIns="381" rIns="381" bIns="381" rtlCol="0" anchor="ctr">
+            <a:normAutofit/>
+          </a:bodyPr>
+          <a:lstStyle/>
+          <a:p>
+            <a:pPr algn="l" indent="0" marL="0">
+              <a:buNone/>
+            </a:pPr>
+            <a:r>
+              <a:rPr lang="en-US" sz="660" b="1" dirty="0">
+                <a:solidFill>
+                  <a:srgbClr val="6D5BD0"/>
+                </a:solidFill>
+                <a:latin typeface="Aptos" pitchFamily="34" charset="0"/>
+                <a:ea typeface="Aptos" pitchFamily="34" charset="-122"/>
+                <a:cs typeface="Aptos" pitchFamily="34" charset="-120"/>
+              </a:rPr>
+              <a:t>1,85</a:t>
+            </a:r>
+            <a:endParaRPr lang="en-US" sz="660" dirty="0"/>
+          </a:p>
+        </p:txBody>
+      </p:sp>
+      <p:sp>
+        <p:nvSpPr>
+          <p:cNvPr id="28" name="Text 26"/>
+          <p:cNvSpPr/>
+          <p:nvPr/>
+        </p:nvSpPr>
+        <p:spPr>
+          <a:xfrm>
+            <a:off x="822960" y="4315968"/>
+            <a:ext cx="2331720" cy="164592"/>
+          </a:xfrm>
+          <a:prstGeom prst="rect">
+            <a:avLst/>
+          </a:prstGeom>
+          <a:noFill/>
+          <a:ln/>
+        </p:spPr>
+        <p:txBody>
+          <a:bodyPr wrap="square" lIns="381" tIns="381" rIns="381" bIns="381" rtlCol="0" anchor="ctr">
+            <a:normAutofit/>
+          </a:bodyPr>
+          <a:lstStyle/>
+          <a:p>
+            <a:pPr algn="l" indent="0" marL="0">
+              <a:buNone/>
+            </a:pPr>
+            <a:r>
+              <a:rPr lang="en-US" sz="660" b="1" dirty="0">
+                <a:solidFill>
+                  <a:srgbClr val="1B2430"/>
+                </a:solidFill>
+                <a:latin typeface="Aptos" pitchFamily="34" charset="0"/>
+                <a:ea typeface="Aptos" pitchFamily="34" charset="-122"/>
+                <a:cs typeface="Aptos" pitchFamily="34" charset="-120"/>
+              </a:rPr>
+              <a:t>dron</a:t>
+            </a:r>
+            <a:endParaRPr lang="en-US" sz="660" dirty="0"/>
+          </a:p>
+        </p:txBody>
+      </p:sp>
+      <p:sp>
+        <p:nvSpPr>
+          <p:cNvPr id="29" name="Shape 27"/>
+          <p:cNvSpPr/>
+          <p:nvPr/>
+        </p:nvSpPr>
+        <p:spPr>
+          <a:xfrm>
+            <a:off x="3493008" y="4352544"/>
+            <a:ext cx="3749040" cy="128016"/>
+          </a:xfrm>
+          <a:prstGeom prst="rect">
+            <a:avLst/>
+          </a:prstGeom>
+          <a:solidFill>
+            <a:srgbClr val="E8EEF4"/>
+          </a:solidFill>
+          <a:ln w="12700">
+            <a:solidFill>
+              <a:srgbClr val="E8EEF4"/>
+            </a:solidFill>
+            <a:prstDash val="solid"/>
+          </a:ln>
+        </p:spPr>
+      </p:sp>
+      <p:sp>
+        <p:nvSpPr>
+          <p:cNvPr id="30" name="Shape 28"/>
+          <p:cNvSpPr/>
+          <p:nvPr/>
+        </p:nvSpPr>
+        <p:spPr>
+          <a:xfrm>
+            <a:off x="3493008" y="4352544"/>
+            <a:ext cx="1444752" cy="128016"/>
           </a:xfrm>
           <a:prstGeom prst="rect">
             <a:avLst/>
@@ -17938,32 +18331,73 @@
       </p:sp>
       <p:sp>
         <p:nvSpPr>
-          <p:cNvPr id="21" name="Text 19"/>
-          <p:cNvSpPr/>
-          <p:nvPr/>
-        </p:nvSpPr>
-        <p:spPr>
-          <a:xfrm>
-            <a:off x="5925312" y="2615184"/>
-            <a:ext cx="4480560" cy="329184"/>
-          </a:xfrm>
-          <a:prstGeom prst="rect">
-            <a:avLst/>
-          </a:prstGeom>
-          <a:noFill/>
-          <a:ln/>
-        </p:spPr>
-        <p:txBody>
-          <a:bodyPr wrap="square" lIns="381" tIns="381" rIns="381" bIns="381" rtlCol="0" anchor="ctr">
-            <a:normAutofit/>
-          </a:bodyPr>
-          <a:lstStyle/>
-          <a:p>
-            <a:pPr algn="l" indent="0" marL="0">
-              <a:buNone/>
-            </a:pPr>
-            <a:r>
-              <a:rPr lang="en-US" sz="820" dirty="0">
+          <p:cNvPr id="31" name="Text 29"/>
+          <p:cNvSpPr/>
+          <p:nvPr/>
+        </p:nvSpPr>
+        <p:spPr>
+          <a:xfrm>
+            <a:off x="7452360" y="4306824"/>
+            <a:ext cx="384048" cy="164592"/>
+          </a:xfrm>
+          <a:prstGeom prst="rect">
+            <a:avLst/>
+          </a:prstGeom>
+          <a:noFill/>
+          <a:ln/>
+        </p:spPr>
+        <p:txBody>
+          <a:bodyPr wrap="square" lIns="381" tIns="381" rIns="381" bIns="381" rtlCol="0" anchor="ctr">
+            <a:normAutofit/>
+          </a:bodyPr>
+          <a:lstStyle/>
+          <a:p>
+            <a:pPr algn="l" indent="0" marL="0">
+              <a:buNone/>
+            </a:pPr>
+            <a:r>
+              <a:rPr lang="en-US" sz="660" b="1" dirty="0">
+                <a:solidFill>
+                  <a:srgbClr val="B91C1C"/>
+                </a:solidFill>
+                <a:latin typeface="Aptos" pitchFamily="34" charset="0"/>
+                <a:ea typeface="Aptos" pitchFamily="34" charset="-122"/>
+                <a:cs typeface="Aptos" pitchFamily="34" charset="-120"/>
+              </a:rPr>
+              <a:t>1,75</a:t>
+            </a:r>
+            <a:endParaRPr lang="en-US" sz="660" dirty="0"/>
+          </a:p>
+        </p:txBody>
+      </p:sp>
+      <p:sp>
+        <p:nvSpPr>
+          <p:cNvPr id="32" name="Text 30"/>
+          <p:cNvSpPr/>
+          <p:nvPr/>
+        </p:nvSpPr>
+        <p:spPr>
+          <a:xfrm>
+            <a:off x="822960" y="4736592"/>
+            <a:ext cx="2331720" cy="164592"/>
+          </a:xfrm>
+          <a:prstGeom prst="rect">
+            <a:avLst/>
+          </a:prstGeom>
+          <a:noFill/>
+          <a:ln/>
+        </p:spPr>
+        <p:txBody>
+          <a:bodyPr wrap="square" lIns="381" tIns="381" rIns="381" bIns="381" rtlCol="0" anchor="ctr">
+            <a:normAutofit/>
+          </a:bodyPr>
+          <a:lstStyle/>
+          <a:p>
+            <a:pPr algn="l" indent="0" marL="0">
+              <a:buNone/>
+            </a:pPr>
+            <a:r>
+              <a:rPr lang="en-US" sz="660" b="1" dirty="0">
                 <a:solidFill>
                   <a:srgbClr val="1B2430"/>
                 </a:solidFill>
@@ -17971,24 +18405,288 @@
                 <a:ea typeface="Aptos" pitchFamily="34" charset="-122"/>
                 <a:cs typeface="Aptos" pitchFamily="34" charset="-120"/>
               </a:rPr>
-              <a:t>Orugas: innecesarias sobre pavimento regular.</a:t>
-            </a:r>
-            <a:endParaRPr lang="en-US" sz="820" dirty="0"/>
-          </a:p>
-        </p:txBody>
-      </p:sp>
-      <p:sp>
-        <p:nvSpPr>
-          <p:cNvPr id="22" name="Shape 20"/>
-          <p:cNvSpPr/>
-          <p:nvPr/>
-        </p:nvSpPr>
-        <p:spPr>
-          <a:xfrm>
-            <a:off x="5669280" y="3392424"/>
+              <a:t>orugas</a:t>
+            </a:r>
+            <a:endParaRPr lang="en-US" sz="660" dirty="0"/>
+          </a:p>
+        </p:txBody>
+      </p:sp>
+      <p:sp>
+        <p:nvSpPr>
+          <p:cNvPr id="33" name="Shape 31"/>
+          <p:cNvSpPr/>
+          <p:nvPr/>
+        </p:nvSpPr>
+        <p:spPr>
+          <a:xfrm>
+            <a:off x="3493008" y="4773168"/>
+            <a:ext cx="3749040" cy="128016"/>
+          </a:xfrm>
+          <a:prstGeom prst="rect">
+            <a:avLst/>
+          </a:prstGeom>
+          <a:solidFill>
+            <a:srgbClr val="E8EEF4"/>
+          </a:solidFill>
+          <a:ln w="12700">
+            <a:solidFill>
+              <a:srgbClr val="E8EEF4"/>
+            </a:solidFill>
+            <a:prstDash val="solid"/>
+          </a:ln>
+        </p:spPr>
+      </p:sp>
+      <p:sp>
+        <p:nvSpPr>
+          <p:cNvPr id="34" name="Shape 32"/>
+          <p:cNvSpPr/>
+          <p:nvPr/>
+        </p:nvSpPr>
+        <p:spPr>
+          <a:xfrm>
+            <a:off x="3493008" y="4773168"/>
+            <a:ext cx="1188720" cy="128016"/>
+          </a:xfrm>
+          <a:prstGeom prst="rect">
+            <a:avLst/>
+          </a:prstGeom>
+          <a:solidFill>
+            <a:srgbClr val="5D6B7A"/>
+          </a:solidFill>
+          <a:ln w="12700">
+            <a:solidFill>
+              <a:srgbClr val="5D6B7A"/>
+            </a:solidFill>
+            <a:prstDash val="solid"/>
+          </a:ln>
+        </p:spPr>
+      </p:sp>
+      <p:sp>
+        <p:nvSpPr>
+          <p:cNvPr id="35" name="Text 33"/>
+          <p:cNvSpPr/>
+          <p:nvPr/>
+        </p:nvSpPr>
+        <p:spPr>
+          <a:xfrm>
+            <a:off x="7452360" y="4727448"/>
+            <a:ext cx="384048" cy="164592"/>
+          </a:xfrm>
+          <a:prstGeom prst="rect">
+            <a:avLst/>
+          </a:prstGeom>
+          <a:noFill/>
+          <a:ln/>
+        </p:spPr>
+        <p:txBody>
+          <a:bodyPr wrap="square" lIns="381" tIns="381" rIns="381" bIns="381" rtlCol="0" anchor="ctr">
+            <a:normAutofit/>
+          </a:bodyPr>
+          <a:lstStyle/>
+          <a:p>
+            <a:pPr algn="l" indent="0" marL="0">
+              <a:buNone/>
+            </a:pPr>
+            <a:r>
+              <a:rPr lang="en-US" sz="660" b="1" dirty="0">
+                <a:solidFill>
+                  <a:srgbClr val="5D6B7A"/>
+                </a:solidFill>
+                <a:latin typeface="Aptos" pitchFamily="34" charset="0"/>
+                <a:ea typeface="Aptos" pitchFamily="34" charset="-122"/>
+                <a:cs typeface="Aptos" pitchFamily="34" charset="-120"/>
+              </a:rPr>
+              <a:t>1,45</a:t>
+            </a:r>
+            <a:endParaRPr lang="en-US" sz="660" dirty="0"/>
+          </a:p>
+        </p:txBody>
+      </p:sp>
+      <p:sp>
+        <p:nvSpPr>
+          <p:cNvPr id="36" name="Text 34"/>
+          <p:cNvSpPr/>
+          <p:nvPr/>
+        </p:nvSpPr>
+        <p:spPr>
+          <a:xfrm>
+            <a:off x="8366760" y="1234440"/>
+            <a:ext cx="2194560" cy="228600"/>
+          </a:xfrm>
+          <a:prstGeom prst="rect">
+            <a:avLst/>
+          </a:prstGeom>
+          <a:noFill/>
+          <a:ln/>
+        </p:spPr>
+        <p:txBody>
+          <a:bodyPr wrap="square" lIns="381" tIns="381" rIns="381" bIns="381" rtlCol="0" anchor="ctr">
+            <a:normAutofit/>
+          </a:bodyPr>
+          <a:lstStyle/>
+          <a:p>
+            <a:pPr algn="l" indent="0" marL="0">
+              <a:buNone/>
+            </a:pPr>
+            <a:r>
+              <a:rPr lang="en-US" sz="950" b="1" dirty="0">
+                <a:solidFill>
+                  <a:srgbClr val="102033"/>
+                </a:solidFill>
+                <a:latin typeface="Aptos" pitchFamily="34" charset="0"/>
+                <a:ea typeface="Aptos" pitchFamily="34" charset="-122"/>
+                <a:cs typeface="Aptos" pitchFamily="34" charset="-120"/>
+              </a:rPr>
+              <a:t>criterios con peso</a:t>
+            </a:r>
+            <a:endParaRPr lang="en-US" sz="950" dirty="0"/>
+          </a:p>
+        </p:txBody>
+      </p:sp>
+      <p:sp>
+        <p:nvSpPr>
+          <p:cNvPr id="37" name="Shape 35"/>
+          <p:cNvSpPr/>
+          <p:nvPr/>
+        </p:nvSpPr>
+        <p:spPr>
+          <a:xfrm>
+            <a:off x="8412480" y="1773936"/>
             <a:ext cx="109728" cy="109728"/>
           </a:xfrm>
-          <a:prstGeom prst="rect">
+          <a:prstGeom prst="ellipse">
+            <a:avLst/>
+          </a:prstGeom>
+          <a:solidFill>
+            <a:srgbClr val="2A9D8F"/>
+          </a:solidFill>
+          <a:ln w="12700">
+            <a:solidFill>
+              <a:srgbClr val="2A9D8F"/>
+            </a:solidFill>
+            <a:prstDash val="solid"/>
+          </a:ln>
+        </p:spPr>
+      </p:sp>
+      <p:sp>
+        <p:nvSpPr>
+          <p:cNvPr id="38" name="Text 36"/>
+          <p:cNvSpPr/>
+          <p:nvPr/>
+        </p:nvSpPr>
+        <p:spPr>
+          <a:xfrm>
+            <a:off x="8641080" y="1719072"/>
+            <a:ext cx="2560320" cy="182880"/>
+          </a:xfrm>
+          <a:prstGeom prst="rect">
+            <a:avLst/>
+          </a:prstGeom>
+          <a:noFill/>
+          <a:ln/>
+        </p:spPr>
+        <p:txBody>
+          <a:bodyPr wrap="square" lIns="381" tIns="381" rIns="381" bIns="381" rtlCol="0" anchor="ctr">
+            <a:normAutofit/>
+          </a:bodyPr>
+          <a:lstStyle/>
+          <a:p>
+            <a:pPr algn="l" indent="0" marL="0">
+              <a:buNone/>
+            </a:pPr>
+            <a:r>
+              <a:rPr lang="en-US" sz="710" b="1" dirty="0">
+                <a:solidFill>
+                  <a:srgbClr val="1B2430"/>
+                </a:solidFill>
+                <a:latin typeface="Aptos" pitchFamily="34" charset="0"/>
+                <a:ea typeface="Aptos" pitchFamily="34" charset="-122"/>
+                <a:cs typeface="Aptos" pitchFamily="34" charset="-120"/>
+              </a:rPr>
+              <a:t>25 % maniobra en estación</a:t>
+            </a:r>
+            <a:endParaRPr lang="en-US" sz="710" dirty="0"/>
+          </a:p>
+        </p:txBody>
+      </p:sp>
+      <p:sp>
+        <p:nvSpPr>
+          <p:cNvPr id="39" name="Shape 37"/>
+          <p:cNvSpPr/>
+          <p:nvPr/>
+        </p:nvSpPr>
+        <p:spPr>
+          <a:xfrm>
+            <a:off x="8412480" y="2377440"/>
+            <a:ext cx="109728" cy="109728"/>
+          </a:xfrm>
+          <a:prstGeom prst="ellipse">
+            <a:avLst/>
+          </a:prstGeom>
+          <a:solidFill>
+            <a:srgbClr val="B91C1C"/>
+          </a:solidFill>
+          <a:ln w="12700">
+            <a:solidFill>
+              <a:srgbClr val="B91C1C"/>
+            </a:solidFill>
+            <a:prstDash val="solid"/>
+          </a:ln>
+        </p:spPr>
+      </p:sp>
+      <p:sp>
+        <p:nvSpPr>
+          <p:cNvPr id="40" name="Text 38"/>
+          <p:cNvSpPr/>
+          <p:nvPr/>
+        </p:nvSpPr>
+        <p:spPr>
+          <a:xfrm>
+            <a:off x="8641080" y="2322576"/>
+            <a:ext cx="2560320" cy="182880"/>
+          </a:xfrm>
+          <a:prstGeom prst="rect">
+            <a:avLst/>
+          </a:prstGeom>
+          <a:noFill/>
+          <a:ln/>
+        </p:spPr>
+        <p:txBody>
+          <a:bodyPr wrap="square" lIns="381" tIns="381" rIns="381" bIns="381" rtlCol="0" anchor="ctr">
+            <a:normAutofit/>
+          </a:bodyPr>
+          <a:lstStyle/>
+          <a:p>
+            <a:pPr algn="l" indent="0" marL="0">
+              <a:buNone/>
+            </a:pPr>
+            <a:r>
+              <a:rPr lang="en-US" sz="710" b="1" dirty="0">
+                <a:solidFill>
+                  <a:srgbClr val="1B2430"/>
+                </a:solidFill>
+                <a:latin typeface="Aptos" pitchFamily="34" charset="0"/>
+                <a:ea typeface="Aptos" pitchFamily="34" charset="-122"/>
+                <a:cs typeface="Aptos" pitchFamily="34" charset="-120"/>
+              </a:rPr>
+              <a:t>20 % seguridad con operarios</a:t>
+            </a:r>
+            <a:endParaRPr lang="en-US" sz="710" dirty="0"/>
+          </a:p>
+        </p:txBody>
+      </p:sp>
+      <p:sp>
+        <p:nvSpPr>
+          <p:cNvPr id="41" name="Shape 39"/>
+          <p:cNvSpPr/>
+          <p:nvPr/>
+        </p:nvSpPr>
+        <p:spPr>
+          <a:xfrm>
+            <a:off x="8412480" y="2980944"/>
+            <a:ext cx="109728" cy="109728"/>
+          </a:xfrm>
+          <a:prstGeom prst="ellipse">
             <a:avLst/>
           </a:prstGeom>
           <a:solidFill>
@@ -18004,32 +18702,32 @@
       </p:sp>
       <p:sp>
         <p:nvSpPr>
-          <p:cNvPr id="23" name="Text 21"/>
-          <p:cNvSpPr/>
-          <p:nvPr/>
-        </p:nvSpPr>
-        <p:spPr>
-          <a:xfrm>
-            <a:off x="5925312" y="3273552"/>
-            <a:ext cx="4480560" cy="329184"/>
-          </a:xfrm>
-          <a:prstGeom prst="rect">
-            <a:avLst/>
-          </a:prstGeom>
-          <a:noFill/>
-          <a:ln/>
-        </p:spPr>
-        <p:txBody>
-          <a:bodyPr wrap="square" lIns="381" tIns="381" rIns="381" bIns="381" rtlCol="0" anchor="ctr">
-            <a:normAutofit/>
-          </a:bodyPr>
-          <a:lstStyle/>
-          <a:p>
-            <a:pPr algn="l" indent="0" marL="0">
-              <a:buNone/>
-            </a:pPr>
-            <a:r>
-              <a:rPr lang="en-US" sz="820" dirty="0">
+          <p:cNvPr id="42" name="Text 40"/>
+          <p:cNvSpPr/>
+          <p:nvPr/>
+        </p:nvSpPr>
+        <p:spPr>
+          <a:xfrm>
+            <a:off x="8641080" y="2926080"/>
+            <a:ext cx="2560320" cy="182880"/>
+          </a:xfrm>
+          <a:prstGeom prst="rect">
+            <a:avLst/>
+          </a:prstGeom>
+          <a:noFill/>
+          <a:ln/>
+        </p:spPr>
+        <p:txBody>
+          <a:bodyPr wrap="square" lIns="381" tIns="381" rIns="381" bIns="381" rtlCol="0" anchor="ctr">
+            <a:normAutofit/>
+          </a:bodyPr>
+          <a:lstStyle/>
+          <a:p>
+            <a:pPr algn="l" indent="0" marL="0">
+              <a:buNone/>
+            </a:pPr>
+            <a:r>
+              <a:rPr lang="en-US" sz="710" b="1" dirty="0">
                 <a:solidFill>
                   <a:srgbClr val="1B2430"/>
                 </a:solidFill>
@@ -18037,9 +18735,141 @@
                 <a:ea typeface="Aptos" pitchFamily="34" charset="-122"/>
                 <a:cs typeface="Aptos" pitchFamily="34" charset="-120"/>
               </a:rPr>
-              <a:t>Patas: coste y complejidad sin ventaja operativa clara.</a:t>
-            </a:r>
-            <a:endParaRPr lang="en-US" sz="820" dirty="0"/>
+              <a:t>15 % trazabilidad e integración</a:t>
+            </a:r>
+            <a:endParaRPr lang="en-US" sz="710" dirty="0"/>
+          </a:p>
+        </p:txBody>
+      </p:sp>
+      <p:sp>
+        <p:nvSpPr>
+          <p:cNvPr id="43" name="Shape 41"/>
+          <p:cNvSpPr/>
+          <p:nvPr/>
+        </p:nvSpPr>
+        <p:spPr>
+          <a:xfrm>
+            <a:off x="8412480" y="3584448"/>
+            <a:ext cx="109728" cy="109728"/>
+          </a:xfrm>
+          <a:prstGeom prst="ellipse">
+            <a:avLst/>
+          </a:prstGeom>
+          <a:solidFill>
+            <a:srgbClr val="1F7A8C"/>
+          </a:solidFill>
+          <a:ln w="12700">
+            <a:solidFill>
+              <a:srgbClr val="1F7A8C"/>
+            </a:solidFill>
+            <a:prstDash val="solid"/>
+          </a:ln>
+        </p:spPr>
+      </p:sp>
+      <p:sp>
+        <p:nvSpPr>
+          <p:cNvPr id="44" name="Text 42"/>
+          <p:cNvSpPr/>
+          <p:nvPr/>
+        </p:nvSpPr>
+        <p:spPr>
+          <a:xfrm>
+            <a:off x="8641080" y="3529584"/>
+            <a:ext cx="2560320" cy="182880"/>
+          </a:xfrm>
+          <a:prstGeom prst="rect">
+            <a:avLst/>
+          </a:prstGeom>
+          <a:noFill/>
+          <a:ln/>
+        </p:spPr>
+        <p:txBody>
+          <a:bodyPr wrap="square" lIns="381" tIns="381" rIns="381" bIns="381" rtlCol="0" anchor="ctr">
+            <a:normAutofit/>
+          </a:bodyPr>
+          <a:lstStyle/>
+          <a:p>
+            <a:pPr algn="l" indent="0" marL="0">
+              <a:buNone/>
+            </a:pPr>
+            <a:r>
+              <a:rPr lang="en-US" sz="710" b="1" dirty="0">
+                <a:solidFill>
+                  <a:srgbClr val="1B2430"/>
+                </a:solidFill>
+                <a:latin typeface="Aptos" pitchFamily="34" charset="0"/>
+                <a:ea typeface="Aptos" pitchFamily="34" charset="-122"/>
+                <a:cs typeface="Aptos" pitchFamily="34" charset="-120"/>
+              </a:rPr>
+              <a:t>15 % madurez comercial</a:t>
+            </a:r>
+            <a:endParaRPr lang="en-US" sz="710" dirty="0"/>
+          </a:p>
+        </p:txBody>
+      </p:sp>
+      <p:sp>
+        <p:nvSpPr>
+          <p:cNvPr id="45" name="Shape 43"/>
+          <p:cNvSpPr/>
+          <p:nvPr/>
+        </p:nvSpPr>
+        <p:spPr>
+          <a:xfrm>
+            <a:off x="8412480" y="4187952"/>
+            <a:ext cx="109728" cy="109728"/>
+          </a:xfrm>
+          <a:prstGeom prst="ellipse">
+            <a:avLst/>
+          </a:prstGeom>
+          <a:solidFill>
+            <a:srgbClr val="F4A261"/>
+          </a:solidFill>
+          <a:ln w="12700">
+            <a:solidFill>
+              <a:srgbClr val="F4A261"/>
+            </a:solidFill>
+            <a:prstDash val="solid"/>
+          </a:ln>
+        </p:spPr>
+      </p:sp>
+      <p:sp>
+        <p:nvSpPr>
+          <p:cNvPr id="46" name="Text 44"/>
+          <p:cNvSpPr/>
+          <p:nvPr/>
+        </p:nvSpPr>
+        <p:spPr>
+          <a:xfrm>
+            <a:off x="8641080" y="4133088"/>
+            <a:ext cx="2560320" cy="182880"/>
+          </a:xfrm>
+          <a:prstGeom prst="rect">
+            <a:avLst/>
+          </a:prstGeom>
+          <a:noFill/>
+          <a:ln/>
+        </p:spPr>
+        <p:txBody>
+          <a:bodyPr wrap="square" lIns="381" tIns="381" rIns="381" bIns="381" rtlCol="0" anchor="ctr">
+            <a:normAutofit/>
+          </a:bodyPr>
+          <a:lstStyle/>
+          <a:p>
+            <a:pPr algn="l" indent="0" marL="0">
+              <a:buNone/>
+            </a:pPr>
+            <a:r>
+              <a:rPr lang="en-US" sz="710" b="1" dirty="0">
+                <a:solidFill>
+                  <a:srgbClr val="1B2430"/>
+                </a:solidFill>
+                <a:latin typeface="Aptos" pitchFamily="34" charset="0"/>
+                <a:ea typeface="Aptos" pitchFamily="34" charset="-122"/>
+                <a:cs typeface="Aptos" pitchFamily="34" charset="-120"/>
+              </a:rPr>
+              <a:t>15 % coste/riesgo de integración</a:t>
+            </a:r>
+            <a:endParaRPr lang="en-US" sz="710" dirty="0"/>
           </a:p>
         </p:txBody>
       </p:sp>
@@ -18172,7 +19002,7 @@
                 <a:ea typeface="Aptos Display" pitchFamily="34" charset="-122"/>
                 <a:cs typeface="Aptos Display" pitchFamily="34" charset="-120"/>
               </a:rPr>
-              <a:t>AMR omnidireccional objetivo</a:t>
+              <a:t>Modelo elegido y opciones reales de compra</a:t>
             </a:r>
             <a:endParaRPr lang="en-US" sz="2000" dirty="0"/>
           </a:p>
@@ -18613,7 +19443,7 @@
               <a:buNone/>
             </a:pPr>
             <a:r>
-              <a:rPr lang="en-US" sz="1600" b="1" dirty="0">
+              <a:rPr lang="en-US" sz="1500" b="1" dirty="0">
                 <a:solidFill>
                   <a:srgbClr val="102033"/>
                 </a:solidFill>
@@ -18621,9 +19451,9 @@
                 <a:ea typeface="Aptos" pitchFamily="34" charset="-122"/>
                 <a:cs typeface="Aptos" pitchFamily="34" charset="-120"/>
               </a:rPr>
-              <a:t>tres niveles, una decisión</a:t>
-            </a:r>
-            <a:endParaRPr lang="en-US" sz="1600" dirty="0"/>
+              <a:t>shortlist defendible</a:t>
+            </a:r>
+            <a:endParaRPr lang="en-US" sz="1500" dirty="0"/>
           </a:p>
         </p:txBody>
       </p:sp>
@@ -18635,7 +19465,73 @@
         </p:nvSpPr>
         <p:spPr>
           <a:xfrm>
-            <a:off x="6446520" y="1920240"/>
+            <a:off x="6446520" y="1874520"/>
+            <a:ext cx="128016" cy="128016"/>
+          </a:xfrm>
+          <a:prstGeom prst="ellipse">
+            <a:avLst/>
+          </a:prstGeom>
+          <a:solidFill>
+            <a:srgbClr val="2A9D8F"/>
+          </a:solidFill>
+          <a:ln w="12700">
+            <a:solidFill>
+              <a:srgbClr val="2A9D8F"/>
+            </a:solidFill>
+            <a:prstDash val="solid"/>
+          </a:ln>
+        </p:spPr>
+      </p:sp>
+      <p:sp>
+        <p:nvSpPr>
+          <p:cNvPr id="19" name="Text 17"/>
+          <p:cNvSpPr/>
+          <p:nvPr/>
+        </p:nvSpPr>
+        <p:spPr>
+          <a:xfrm>
+            <a:off x="6720840" y="1746504"/>
+            <a:ext cx="4480560" cy="292608"/>
+          </a:xfrm>
+          <a:prstGeom prst="rect">
+            <a:avLst/>
+          </a:prstGeom>
+          <a:noFill/>
+          <a:ln/>
+        </p:spPr>
+        <p:txBody>
+          <a:bodyPr wrap="square" lIns="381" tIns="381" rIns="381" bIns="381" rtlCol="0" anchor="ctr">
+            <a:normAutofit/>
+          </a:bodyPr>
+          <a:lstStyle/>
+          <a:p>
+            <a:pPr algn="l" indent="0" marL="0">
+              <a:buNone/>
+            </a:pPr>
+            <a:r>
+              <a:rPr lang="en-US" sz="750" dirty="0">
+                <a:solidFill>
+                  <a:srgbClr val="1B2430"/>
+                </a:solidFill>
+                <a:latin typeface="Aptos" pitchFamily="34" charset="0"/>
+                <a:ea typeface="Aptos" pitchFamily="34" charset="-122"/>
+                <a:cs typeface="Aptos" pitchFamily="34" charset="-120"/>
+              </a:rPr>
+              <a:t>Recomendado: RB-KAIROS-class: 250 kg, 1,5 m/s, ROS 2, omni.</a:t>
+            </a:r>
+            <a:endParaRPr lang="en-US" sz="750" dirty="0"/>
+          </a:p>
+        </p:txBody>
+      </p:sp>
+      <p:sp>
+        <p:nvSpPr>
+          <p:cNvPr id="20" name="Shape 18"/>
+          <p:cNvSpPr/>
+          <p:nvPr/>
+        </p:nvSpPr>
+        <p:spPr>
+          <a:xfrm>
+            <a:off x="6446520" y="2441448"/>
             <a:ext cx="128016" cy="128016"/>
           </a:xfrm>
           <a:prstGeom prst="ellipse">
@@ -18654,32 +19550,32 @@
       </p:sp>
       <p:sp>
         <p:nvSpPr>
-          <p:cNvPr id="19" name="Text 17"/>
-          <p:cNvSpPr/>
-          <p:nvPr/>
-        </p:nvSpPr>
-        <p:spPr>
-          <a:xfrm>
-            <a:off x="6720840" y="1792224"/>
-            <a:ext cx="4206240" cy="329184"/>
-          </a:xfrm>
-          <a:prstGeom prst="rect">
-            <a:avLst/>
-          </a:prstGeom>
-          <a:noFill/>
-          <a:ln/>
-        </p:spPr>
-        <p:txBody>
-          <a:bodyPr wrap="square" lIns="381" tIns="381" rIns="381" bIns="381" rtlCol="0" anchor="ctr">
-            <a:normAutofit/>
-          </a:bodyPr>
-          <a:lstStyle/>
-          <a:p>
-            <a:pPr algn="l" indent="0" marL="0">
-              <a:buNone/>
-            </a:pPr>
-            <a:r>
-              <a:rPr lang="en-US" sz="800" dirty="0">
+          <p:cNvPr id="21" name="Text 19"/>
+          <p:cNvSpPr/>
+          <p:nvPr/>
+        </p:nvSpPr>
+        <p:spPr>
+          <a:xfrm>
+            <a:off x="6720840" y="2313432"/>
+            <a:ext cx="4480560" cy="292608"/>
+          </a:xfrm>
+          <a:prstGeom prst="rect">
+            <a:avLst/>
+          </a:prstGeom>
+          <a:noFill/>
+          <a:ln/>
+        </p:spPr>
+        <p:txBody>
+          <a:bodyPr wrap="square" lIns="381" tIns="381" rIns="381" bIns="381" rtlCol="0" anchor="ctr">
+            <a:normAutofit/>
+          </a:bodyPr>
+          <a:lstStyle/>
+          <a:p>
+            <a:pPr algn="l" indent="0" marL="0">
+              <a:buNone/>
+            </a:pPr>
+            <a:r>
+              <a:rPr lang="en-US" sz="750" dirty="0">
                 <a:solidFill>
                   <a:srgbClr val="1B2430"/>
                 </a:solidFill>
@@ -18687,21 +19583,21 @@
                 <a:ea typeface="Aptos" pitchFamily="34" charset="-122"/>
                 <a:cs typeface="Aptos" pitchFamily="34" charset="-120"/>
               </a:rPr>
-              <a:t>Simulacion: YouBot/Omnirob o base mecanum equivalente.</a:t>
-            </a:r>
-            <a:endParaRPr lang="en-US" sz="800" dirty="0"/>
-          </a:p>
-        </p:txBody>
-      </p:sp>
-      <p:sp>
-        <p:nvSpPr>
-          <p:cNvPr id="20" name="Shape 18"/>
-          <p:cNvSpPr/>
-          <p:nvPr/>
-        </p:nvSpPr>
-        <p:spPr>
-          <a:xfrm>
-            <a:off x="6446520" y="2606040"/>
+              <a:t>Alternativa: AGILOX ODM: 300 kg, 1,4 m/s, intralogística.</a:t>
+            </a:r>
+            <a:endParaRPr lang="en-US" sz="750" dirty="0"/>
+          </a:p>
+        </p:txBody>
+      </p:sp>
+      <p:sp>
+        <p:nvSpPr>
+          <p:cNvPr id="22" name="Shape 20"/>
+          <p:cNvSpPr/>
+          <p:nvPr/>
+        </p:nvSpPr>
+        <p:spPr>
+          <a:xfrm>
+            <a:off x="6446520" y="3008376"/>
             <a:ext cx="128016" cy="128016"/>
           </a:xfrm>
           <a:prstGeom prst="ellipse">
@@ -18720,32 +19616,32 @@
       </p:sp>
       <p:sp>
         <p:nvSpPr>
-          <p:cNvPr id="21" name="Text 19"/>
-          <p:cNvSpPr/>
-          <p:nvPr/>
-        </p:nvSpPr>
-        <p:spPr>
-          <a:xfrm>
-            <a:off x="6720840" y="2478024"/>
-            <a:ext cx="4206240" cy="329184"/>
-          </a:xfrm>
-          <a:prstGeom prst="rect">
-            <a:avLst/>
-          </a:prstGeom>
-          <a:noFill/>
-          <a:ln/>
-        </p:spPr>
-        <p:txBody>
-          <a:bodyPr wrap="square" lIns="381" tIns="381" rIns="381" bIns="381" rtlCol="0" anchor="ctr">
-            <a:normAutofit/>
-          </a:bodyPr>
-          <a:lstStyle/>
-          <a:p>
-            <a:pPr algn="l" indent="0" marL="0">
-              <a:buNone/>
-            </a:pPr>
-            <a:r>
-              <a:rPr lang="en-US" sz="800" dirty="0">
+          <p:cNvPr id="23" name="Text 21"/>
+          <p:cNvSpPr/>
+          <p:nvPr/>
+        </p:nvSpPr>
+        <p:spPr>
+          <a:xfrm>
+            <a:off x="6720840" y="2880360"/>
+            <a:ext cx="4480560" cy="292608"/>
+          </a:xfrm>
+          <a:prstGeom prst="rect">
+            <a:avLst/>
+          </a:prstGeom>
+          <a:noFill/>
+          <a:ln/>
+        </p:spPr>
+        <p:txBody>
+          <a:bodyPr wrap="square" lIns="381" tIns="381" rIns="381" bIns="381" rtlCol="0" anchor="ctr">
+            <a:normAutofit/>
+          </a:bodyPr>
+          <a:lstStyle/>
+          <a:p>
+            <a:pPr algn="l" indent="0" marL="0">
+              <a:buNone/>
+            </a:pPr>
+            <a:r>
+              <a:rPr lang="en-US" sz="750" dirty="0">
                 <a:solidFill>
                   <a:srgbClr val="1B2430"/>
                 </a:solidFill>
@@ -18753,32 +19649,32 @@
                 <a:ea typeface="Aptos" pitchFamily="34" charset="-122"/>
                 <a:cs typeface="Aptos" pitchFamily="34" charset="-120"/>
               </a:rPr>
-              <a:t>Benchmark: MiR250 y LD-250 solo para coste AMR 250 kg.</a:t>
-            </a:r>
-            <a:endParaRPr lang="en-US" sz="800" dirty="0"/>
-          </a:p>
-        </p:txBody>
-      </p:sp>
-      <p:sp>
-        <p:nvSpPr>
-          <p:cNvPr id="22" name="Shape 20"/>
-          <p:cNvSpPr/>
-          <p:nvPr/>
-        </p:nvSpPr>
-        <p:spPr>
-          <a:xfrm>
-            <a:off x="6446520" y="3291840"/>
+              <a:t>Benchmark: MiR250 y LD-250 solo para coste/carga AMR 250 kg.</a:t>
+            </a:r>
+            <a:endParaRPr lang="en-US" sz="750" dirty="0"/>
+          </a:p>
+        </p:txBody>
+      </p:sp>
+      <p:sp>
+        <p:nvSpPr>
+          <p:cNvPr id="24" name="Shape 22"/>
+          <p:cNvSpPr/>
+          <p:nvPr/>
+        </p:nvSpPr>
+        <p:spPr>
+          <a:xfrm>
+            <a:off x="6446520" y="3575304"/>
             <a:ext cx="128016" cy="128016"/>
           </a:xfrm>
           <a:prstGeom prst="ellipse">
             <a:avLst/>
           </a:prstGeom>
           <a:solidFill>
-            <a:srgbClr val="2A9D8F"/>
+            <a:srgbClr val="B91C1C"/>
           </a:solidFill>
           <a:ln w="12700">
             <a:solidFill>
-              <a:srgbClr val="2A9D8F"/>
+              <a:srgbClr val="B91C1C"/>
             </a:solidFill>
             <a:prstDash val="solid"/>
           </a:ln>
@@ -18786,32 +19682,32 @@
       </p:sp>
       <p:sp>
         <p:nvSpPr>
-          <p:cNvPr id="23" name="Text 21"/>
-          <p:cNvSpPr/>
-          <p:nvPr/>
-        </p:nvSpPr>
-        <p:spPr>
-          <a:xfrm>
-            <a:off x="6720840" y="3163824"/>
-            <a:ext cx="4206240" cy="329184"/>
-          </a:xfrm>
-          <a:prstGeom prst="rect">
-            <a:avLst/>
-          </a:prstGeom>
-          <a:noFill/>
-          <a:ln/>
-        </p:spPr>
-        <p:txBody>
-          <a:bodyPr wrap="square" lIns="381" tIns="381" rIns="381" bIns="381" rtlCol="0" anchor="ctr">
-            <a:normAutofit/>
-          </a:bodyPr>
-          <a:lstStyle/>
-          <a:p>
-            <a:pPr algn="l" indent="0" marL="0">
-              <a:buNone/>
-            </a:pPr>
-            <a:r>
-              <a:rPr lang="en-US" sz="800" dirty="0">
+          <p:cNvPr id="25" name="Text 23"/>
+          <p:cNvSpPr/>
+          <p:nvPr/>
+        </p:nvSpPr>
+        <p:spPr>
+          <a:xfrm>
+            <a:off x="6720840" y="3447288"/>
+            <a:ext cx="4480560" cy="292608"/>
+          </a:xfrm>
+          <a:prstGeom prst="rect">
+            <a:avLst/>
+          </a:prstGeom>
+          <a:noFill/>
+          <a:ln/>
+        </p:spPr>
+        <p:txBody>
+          <a:bodyPr wrap="square" lIns="381" tIns="381" rIns="381" bIns="381" rtlCol="0" anchor="ctr">
+            <a:normAutofit/>
+          </a:bodyPr>
+          <a:lstStyle/>
+          <a:p>
+            <a:pPr algn="l" indent="0" marL="0">
+              <a:buNone/>
+            </a:pPr>
+            <a:r>
+              <a:rPr lang="en-US" sz="750" dirty="0">
                 <a:solidFill>
                   <a:srgbClr val="1B2430"/>
                 </a:solidFill>
@@ -18819,9 +19715,50 @@
                 <a:ea typeface="Aptos" pitchFamily="34" charset="-122"/>
                 <a:cs typeface="Aptos" pitchFamily="34" charset="-120"/>
               </a:rPr>
-              <a:t>Implantacion: plataforma holonomica 200-300 kg con portakits.</a:t>
-            </a:r>
-            <a:endParaRPr lang="en-US" sz="800" dirty="0"/>
+              <a:t>Descartado: KUKA omniMove: XXL y caro para kits.</a:t>
+            </a:r>
+            <a:endParaRPr lang="en-US" sz="750" dirty="0"/>
+          </a:p>
+        </p:txBody>
+      </p:sp>
+      <p:sp>
+        <p:nvSpPr>
+          <p:cNvPr id="26" name="Text 24"/>
+          <p:cNvSpPr/>
+          <p:nvPr/>
+        </p:nvSpPr>
+        <p:spPr>
+          <a:xfrm>
+            <a:off x="6419088" y="4498848"/>
+            <a:ext cx="4663440" cy="438912"/>
+          </a:xfrm>
+          <a:prstGeom prst="rect">
+            <a:avLst/>
+          </a:prstGeom>
+          <a:noFill/>
+          <a:ln/>
+        </p:spPr>
+        <p:txBody>
+          <a:bodyPr wrap="square" lIns="381" tIns="381" rIns="381" bIns="381" rtlCol="0" anchor="ctr">
+            <a:normAutofit/>
+          </a:bodyPr>
+          <a:lstStyle/>
+          <a:p>
+            <a:pPr algn="l" indent="0" marL="0">
+              <a:buNone/>
+            </a:pPr>
+            <a:r>
+              <a:rPr lang="en-US" sz="650" dirty="0">
+                <a:solidFill>
+                  <a:srgbClr val="5D6B7A"/>
+                </a:solidFill>
+                <a:latin typeface="Aptos" pitchFamily="34" charset="0"/>
+                <a:ea typeface="Aptos" pitchFamily="34" charset="-122"/>
+                <a:cs typeface="Aptos" pitchFamily="34" charset="-120"/>
+              </a:rPr>
+              <a:t>La licitacion exige base holonomica, safety pack, portakits, vx/vy/w, trazabilidad y pruebas FAT/SAT.</a:t>
+            </a:r>
+            <a:endParaRPr lang="en-US" sz="650" dirty="0"/>
           </a:p>
         </p:txBody>
       </p:sp>

</xml_diff>

<commit_message>
Polish Activity 1 writing style
Tighten Spanish prose across the Activity 1 report and slides, remove AI-like formulaic phrasing, fix a deployment accent issue, and regenerate the compiled PDF/PPTX outputs.
</commit_message>
<xml_diff>
--- a/actividad1/slides/Actividad1_AMR_FOD_Kitting_editable.pptx
+++ b/actividad1/slides/Actividad1_AMR_FOD_Kitting_editable.pptx
@@ -4157,7 +4157,7 @@
                 <a:ea typeface="Aptos" pitchFamily="34" charset="-122"/>
                 <a:cs typeface="Aptos" pitchFamily="34" charset="-120"/>
               </a:rPr>
-              <a:t>La misión termina con evidencia:</a:t>
+              <a:t>Cierre con evidencia:</a:t>
             </a:r>
             <a:endParaRPr lang="en-US" sz="800" dirty="0"/>
           </a:p>
@@ -10000,7 +10000,7 @@
         <p:spPr>
           <a:xfrm>
             <a:off x="4617720" y="5230368"/>
-            <a:ext cx="4846320" cy="164592"/>
+            <a:ext cx="5852160" cy="164592"/>
           </a:xfrm>
           <a:prstGeom prst="rect">
             <a:avLst/>
@@ -10026,7 +10026,7 @@
                 <a:ea typeface="Aptos" pitchFamily="34" charset="-122"/>
                 <a:cs typeface="Aptos" pitchFamily="34" charset="-120"/>
               </a:rPr>
-              <a:t>Lectura: con solo horas recuperadas el VAN central sigue exigente.</a:t>
+              <a:t>Lectura financiera: las horas recuperadas no venden por si solas 7 o 17 robots.</a:t>
             </a:r>
             <a:endParaRPr lang="en-US" sz="630" dirty="0"/>
           </a:p>
@@ -10067,7 +10067,7 @@
                 <a:ea typeface="Aptos" pitchFamily="34" charset="-122"/>
                 <a:cs typeface="Aptos" pitchFamily="34" charset="-120"/>
               </a:rPr>
-              <a:t>7 o 17 robots requieren menos esperas, continuidad de flujo y menor riesgo FOD.</a:t>
+              <a:t>La ampliacion exige datos de espera, continuidad de flujo y riesgo FOD.</a:t>
             </a:r>
             <a:endParaRPr lang="en-US" sz="630" dirty="0"/>
           </a:p>
@@ -12739,7 +12739,7 @@
                 <a:ea typeface="Aptos Display" pitchFamily="34" charset="-122"/>
                 <a:cs typeface="Aptos Display" pitchFamily="34" charset="-120"/>
               </a:rPr>
-              <a:t>La propuesta no robotiza el HTP: ordena el flujo que lo rodea</a:t>
+              <a:t>No se robotiza el HTP; se estabiliza el flujo que lo rodea</a:t>
             </a:r>
             <a:endParaRPr lang="en-US" sz="2000" dirty="0"/>
           </a:p>
@@ -12972,7 +12972,7 @@
                 <a:ea typeface="Aptos" pitchFamily="34" charset="-122"/>
                 <a:cs typeface="Aptos" pitchFamily="34" charset="-120"/>
               </a:rPr>
-              <a:t>Automatiza transporte, confirmación y evidencia.</a:t>
+              <a:t>Cubre transporte, confirmación y evidencia.</a:t>
             </a:r>
             <a:endParaRPr lang="en-US" sz="900" dirty="0"/>
           </a:p>
@@ -13013,7 +13013,7 @@
                 <a:ea typeface="Aptos" pitchFamily="34" charset="-122"/>
                 <a:cs typeface="Aptos" pitchFamily="34" charset="-120"/>
               </a:rPr>
-              <a:t>No invade montaje aeronáutico certificado.</a:t>
+              <a:t>No toca montaje aeronáutico certificado.</a:t>
             </a:r>
             <a:endParaRPr lang="en-US" sz="900" dirty="0"/>
           </a:p>
@@ -15003,7 +15003,7 @@
                 <a:ea typeface="Aptos" pitchFamily="34" charset="-122"/>
                 <a:cs typeface="Aptos" pitchFamily="34" charset="-120"/>
               </a:rPr>
-              <a:t>Lectura clave para la propuesta</a:t>
+              <a:t>Lectura clave de planta</a:t>
             </a:r>
             <a:endParaRPr lang="en-US" sz="740" dirty="0"/>
           </a:p>

</xml_diff>

<commit_message>
Address Activity 1 rubric audit
Rework the interview to follow the guide prompt, remove AI-writing patterns, trim redundant sections, add report visuals, adjust ROI narrative, and regenerate report/slides artifacts.
</commit_message>
<xml_diff>
--- a/actividad1/slides/Actividad1_AMR_FOD_Kitting_editable.pptx
+++ b/actividad1/slides/Actividad1_AMR_FOD_Kitting_editable.pptx
@@ -4198,7 +4198,7 @@
                 <a:ea typeface="Aptos" pitchFamily="34" charset="-122"/>
                 <a:cs typeface="Aptos" pitchFamily="34" charset="-120"/>
               </a:rPr>
-              <a:t>entrega confirmada + ruta registrada + excepcion documentada.</a:t>
+              <a:t>entrega confirmada + ruta registrada + excepcion justificada.</a:t>
             </a:r>
             <a:endParaRPr lang="en-US" sz="800" dirty="0"/>
           </a:p>
@@ -6231,7 +6231,7 @@
                 <a:ea typeface="Aptos" pitchFamily="34" charset="-122"/>
                 <a:cs typeface="Aptos" pitchFamily="34" charset="-120"/>
               </a:rPr>
-              <a:t>Riesgo: comprar antes de medir.</a:t>
+              <a:t>Riesgo: ampliar antes de medir.</a:t>
             </a:r>
             <a:endParaRPr lang="en-US" sz="620" dirty="0"/>
           </a:p>
@@ -8678,7 +8678,7 @@
                 <a:ea typeface="Aptos" pitchFamily="34" charset="-122"/>
                 <a:cs typeface="Aptos" pitchFamily="34" charset="-120"/>
               </a:rPr>
-              <a:t>No es cotizacion vinculante.</a:t>
+              <a:t>Estimacion preliminar.</a:t>
             </a:r>
             <a:endParaRPr lang="en-US" sz="640" dirty="0"/>
           </a:p>
@@ -9220,7 +9220,7 @@
                 <a:ea typeface="Aptos" pitchFamily="34" charset="-122"/>
                 <a:cs typeface="Aptos" pitchFamily="34" charset="-120"/>
               </a:rPr>
-              <a:t>Se monetiza tiempo improductivo; no reducción de plantilla.</a:t>
+              <a:t>Se monetiza tiempo recuperado y continuidad de flujo.</a:t>
             </a:r>
             <a:endParaRPr lang="en-US" sz="670" dirty="0"/>
           </a:p>
@@ -10026,7 +10026,7 @@
                 <a:ea typeface="Aptos" pitchFamily="34" charset="-122"/>
                 <a:cs typeface="Aptos" pitchFamily="34" charset="-120"/>
               </a:rPr>
-              <a:t>Lectura financiera: las horas recuperadas no venden por si solas 7 o 17 robots.</a:t>
+              <a:t>Lectura financiera: las horas recuperadas abren el caso de 7 o 17 robots.</a:t>
             </a:r>
             <a:endParaRPr lang="en-US" sz="630" dirty="0"/>
           </a:p>
@@ -10829,7 +10829,7 @@
                 <a:ea typeface="Aptos" pitchFamily="34" charset="-122"/>
                 <a:cs typeface="Aptos" pitchFamily="34" charset="-120"/>
               </a:rPr>
-              <a:t>rondas con imagen y validación humana</a:t>
+              <a:t>rondas con imagen y revision humana</a:t>
             </a:r>
             <a:endParaRPr lang="en-US" sz="580" dirty="0"/>
           </a:p>
@@ -13978,7 +13978,7 @@
                 <a:ea typeface="Aptos" pitchFamily="34" charset="-122"/>
                 <a:cs typeface="Aptos" pitchFamily="34" charset="-120"/>
               </a:rPr>
-              <a:t>FOD exige inspección, disciplina y evidencia documentada.</a:t>
+              <a:t>FOD exige inspección, disciplina y evidencia revisable.</a:t>
             </a:r>
             <a:endParaRPr lang="en-US" sz="840" dirty="0"/>
           </a:p>

</xml_diff>

<commit_message>
Reduce AI writing patterns in Activity 1
Trim repeated disclaimers, rewrite formulaic transitions, humanize the interview transcript, reduce overused terminology, and regenerate report/slides artifacts.
</commit_message>
<xml_diff>
--- a/actividad1/slides/Actividad1_AMR_FOD_Kitting_editable.pptx
+++ b/actividad1/slides/Actividad1_AMR_FOD_Kitting_editable.pptx
@@ -5521,7 +5521,7 @@
                 <a:ea typeface="Aptos" pitchFamily="34" charset="-122"/>
                 <a:cs typeface="Aptos" pitchFamily="34" charset="-120"/>
               </a:rPr>
-              <a:t>Zona acotada y 1-2 estaciones.</a:t>
+              <a:t>Zona reducida y 1-2 estaciones.</a:t>
             </a:r>
             <a:endParaRPr lang="en-US" sz="640" dirty="0"/>
           </a:p>
@@ -6313,7 +6313,7 @@
                 <a:ea typeface="Aptos" pitchFamily="34" charset="-122"/>
                 <a:cs typeface="Aptos" pitchFamily="34" charset="-120"/>
               </a:rPr>
-              <a:t>Regla comercial: no se escala por intuicion.</a:t>
+              <a:t>Regla comercial: escalar con trazas.</a:t>
             </a:r>
             <a:endParaRPr lang="en-US" sz="710" dirty="0"/>
           </a:p>
@@ -7339,7 +7339,7 @@
                 <a:ea typeface="Aptos" pitchFamily="34" charset="-122"/>
                 <a:cs typeface="Aptos" pitchFamily="34" charset="-120"/>
               </a:rPr>
-              <a:t>Software flota + trazabilidad</a:t>
+              <a:t>Software flota + registro</a:t>
             </a:r>
             <a:endParaRPr lang="en-US" sz="580" dirty="0"/>
           </a:p>
@@ -10681,7 +10681,7 @@
                 <a:ea typeface="Aptos" pitchFamily="34" charset="-122"/>
                 <a:cs typeface="Aptos" pitchFamily="34" charset="-120"/>
               </a:rPr>
-              <a:t>Trazabilidad</a:t>
+              <a:t>Registro</a:t>
             </a:r>
             <a:endParaRPr lang="en-US" sz="660" dirty="0"/>
           </a:p>
@@ -11362,7 +11362,7 @@
                 <a:ea typeface="Aptos" pitchFamily="34" charset="-122"/>
                 <a:cs typeface="Aptos" pitchFamily="34" charset="-120"/>
               </a:rPr>
-              <a:t>Trazabilidad</a:t>
+              <a:t>Registro</a:t>
             </a:r>
             <a:endParaRPr lang="en-US" sz="600" dirty="0"/>
           </a:p>
@@ -11403,7 +11403,7 @@
                 <a:ea typeface="Aptos" pitchFamily="34" charset="-122"/>
                 <a:cs typeface="Aptos" pitchFamily="34" charset="-120"/>
               </a:rPr>
-              <a:t>&gt;= 98 % con registro completo</a:t>
+              <a:t>&gt;= 98 % completo</a:t>
             </a:r>
             <a:endParaRPr lang="en-US" sz="590" dirty="0"/>
           </a:p>
@@ -11756,7 +11756,7 @@
         <p:spPr>
           <a:xfrm>
             <a:off x="7571232" y="5047488"/>
-            <a:ext cx="3383280" cy="164592"/>
+            <a:ext cx="3931920" cy="164592"/>
           </a:xfrm>
           <a:prstGeom prst="rect">
             <a:avLst/>
@@ -11782,7 +11782,7 @@
                 <a:ea typeface="Aptos" pitchFamily="34" charset="-122"/>
                 <a:cs typeface="Aptos" pitchFamily="34" charset="-120"/>
               </a:rPr>
-              <a:t>Exclusion explicita: no se certifica montaje HTP.</a:t>
+              <a:t>Alcance del piloto: entregas, retorno, FOD y registro.</a:t>
             </a:r>
             <a:endParaRPr lang="en-US" sz="600" dirty="0"/>
           </a:p>
@@ -12198,7 +12198,7 @@
                 <a:ea typeface="Aptos" pitchFamily="34" charset="-122"/>
                 <a:cs typeface="Aptos" pitchFamily="34" charset="-120"/>
               </a:rPr>
-              <a:t>Medir trazabilidad, FOD y aceptación.</a:t>
+              <a:t>Medir registro, FOD y aceptación.</a:t>
             </a:r>
             <a:endParaRPr lang="en-US" sz="900" dirty="0"/>
           </a:p>
@@ -12522,7 +12522,7 @@
                 <a:ea typeface="Aptos" pitchFamily="34" charset="-122"/>
                 <a:cs typeface="Aptos" pitchFamily="34" charset="-120"/>
               </a:rPr>
-              <a:t>sin tocar montaje</a:t>
+              <a:t>logística auxiliar</a:t>
             </a:r>
             <a:endParaRPr lang="en-US" sz="680" dirty="0"/>
           </a:p>
@@ -12739,7 +12739,7 @@
                 <a:ea typeface="Aptos Display" pitchFamily="34" charset="-122"/>
                 <a:cs typeface="Aptos Display" pitchFamily="34" charset="-120"/>
               </a:rPr>
-              <a:t>No se robotiza el HTP; se estabiliza el flujo que lo rodea</a:t>
+              <a:t>Estabilizar el flujo que rodea al HTP</a:t>
             </a:r>
             <a:endParaRPr lang="en-US" sz="2000" dirty="0"/>
           </a:p>
@@ -12914,7 +12914,7 @@
                 <a:ea typeface="Aptos Display" pitchFamily="34" charset="-122"/>
                 <a:cs typeface="Aptos Display" pitchFamily="34" charset="-120"/>
               </a:rPr>
-              <a:t>Más trazabilidad.</a:t>
+              <a:t>Mejor registro.</a:t>
             </a:r>
             <a:endParaRPr lang="en-US" sz="2000" dirty="0"/>
           </a:p>
@@ -14044,7 +14044,7 @@
                 <a:ea typeface="Aptos" pitchFamily="34" charset="-122"/>
                 <a:cs typeface="Aptos" pitchFamily="34" charset="-120"/>
               </a:rPr>
-              <a:t>La trazabilidad fina se pierde si la entrega no queda ligada a misión.</a:t>
+              <a:t>El registro se pierde si la entrega no queda ligada a una misión.</a:t>
             </a:r>
             <a:endParaRPr lang="en-US" sz="840" dirty="0"/>
           </a:p>
@@ -14463,7 +14463,7 @@
                 <a:ea typeface="Aptos" pitchFamily="34" charset="-122"/>
                 <a:cs typeface="Aptos" pitchFamily="34" charset="-120"/>
               </a:rPr>
-              <a:t>El AMR no toca montaje certificado.</a:t>
+              <a:t>El AMR trabaja en logística auxiliar.</a:t>
             </a:r>
             <a:endParaRPr lang="en-US" sz="840" dirty="0"/>
           </a:p>
@@ -14504,7 +14504,7 @@
                 <a:ea typeface="Aptos" pitchFamily="34" charset="-122"/>
                 <a:cs typeface="Aptos" pitchFamily="34" charset="-120"/>
               </a:rPr>
-              <a:t>Estabiliza entregas, retornos, FOD y trazabilidad.</a:t>
+              <a:t>Estabiliza entregas, retornos, FOD y registro.</a:t>
             </a:r>
             <a:endParaRPr lang="en-US" sz="810" dirty="0"/>
           </a:p>
@@ -15085,7 +15085,7 @@
                 <a:ea typeface="Aptos" pitchFamily="34" charset="-122"/>
                 <a:cs typeface="Aptos" pitchFamily="34" charset="-120"/>
               </a:rPr>
-              <a:t>El AMR reduce esperas y deja trazas; no fabrica el HTP.</a:t>
+              <a:t>El AMR reduce esperas y deja trazas de entrega.</a:t>
             </a:r>
             <a:endParaRPr lang="en-US" sz="690" dirty="0"/>
           </a:p>
@@ -15453,7 +15453,7 @@
                 <a:ea typeface="Aptos Display" pitchFamily="34" charset="-122"/>
                 <a:cs typeface="Aptos Display" pitchFamily="34" charset="-120"/>
               </a:rPr>
-              <a:t>El alcance correcto no es fabricar: es asegurar flujo, FOD y trazabilidad.</a:t>
+              <a:t>El alcance correcto: asegurar flujo, FOD y registro.</a:t>
             </a:r>
             <a:endParaRPr lang="en-US" sz="1750" dirty="0"/>
           </a:p>
@@ -17406,7 +17406,7 @@
                 <a:ea typeface="Aptos Display" pitchFamily="34" charset="-122"/>
                 <a:cs typeface="Aptos Display" pitchFamily="34" charset="-120"/>
               </a:rPr>
-              <a:t>Matriz de decisión, no seleccion por intuicion</a:t>
+              <a:t>Matriz de decisión con criterios ponderados</a:t>
             </a:r>
             <a:endParaRPr lang="en-US" sz="2000" dirty="0"/>
           </a:p>
@@ -17704,7 +17704,7 @@
                 <a:ea typeface="Aptos" pitchFamily="34" charset="-122"/>
                 <a:cs typeface="Aptos" pitchFamily="34" charset="-120"/>
               </a:rPr>
-              <a:t>Gana por maniobra en estación y representabilidad en CoppeliaSim; no por ser la opcion mas barata.</a:t>
+              <a:t>Se prioriza maniobra en estación y representabilidad en CoppeliaSim, aunque no sea la opcion mas barata.</a:t>
             </a:r>
             <a:endParaRPr lang="en-US" sz="640" dirty="0"/>
           </a:p>
@@ -18735,7 +18735,7 @@
                 <a:ea typeface="Aptos" pitchFamily="34" charset="-122"/>
                 <a:cs typeface="Aptos" pitchFamily="34" charset="-120"/>
               </a:rPr>
-              <a:t>15 % trazabilidad e integración</a:t>
+              <a:t>15 % registro e integración</a:t>
             </a:r>
             <a:endParaRPr lang="en-US" sz="710" dirty="0"/>
           </a:p>
@@ -19756,7 +19756,7 @@
                 <a:ea typeface="Aptos" pitchFamily="34" charset="-122"/>
                 <a:cs typeface="Aptos" pitchFamily="34" charset="-120"/>
               </a:rPr>
-              <a:t>La licitacion exige base holonomica, safety pack, portakits, vx/vy/w, trazabilidad y pruebas FAT/SAT.</a:t>
+              <a:t>La licitacion exige base holonomica, safety pack, portakits, vx/vy/w, registro de entregas y pruebas FAT/SAT.</a:t>
             </a:r>
             <a:endParaRPr lang="en-US" sz="650" dirty="0"/>
           </a:p>

</xml_diff>

<commit_message>
Add webcam placeholder to activity 1 slides
</commit_message>
<xml_diff>
--- a/actividad1/slides/Actividad1_AMR_FOD_Kitting_editable.pptx
+++ b/actividad1/slides/Actividad1_AMR_FOD_Kitting_editable.pptx
@@ -2977,6 +2977,89 @@
           </a:p>
         </p:txBody>
       </p:sp>
+      <p:sp>
+        <p:nvSpPr>
+          <p:cNvPr id="26" name="Shape 24"/>
+          <p:cNvSpPr/>
+          <p:nvPr/>
+        </p:nvSpPr>
+        <p:spPr>
+          <a:xfrm>
+            <a:off x="11155680" y="5632704"/>
+            <a:ext cx="841248" cy="841248"/>
+          </a:xfrm>
+          <a:prstGeom prst="ellipse">
+            <a:avLst/>
+          </a:prstGeom>
+          <a:solidFill>
+            <a:srgbClr val="1B2430">
+              <a:alpha val="14000"/>
+            </a:srgbClr>
+          </a:solidFill>
+          <a:ln w="12700">
+            <a:solidFill>
+              <a:srgbClr val="1B2430">
+                <a:alpha val="0"/>
+              </a:srgbClr>
+            </a:solidFill>
+            <a:prstDash val="solid"/>
+          </a:ln>
+        </p:spPr>
+      </p:sp>
+      <p:sp>
+        <p:nvSpPr>
+          <p:cNvPr id="27" name="Shape 25"/>
+          <p:cNvSpPr/>
+          <p:nvPr/>
+        </p:nvSpPr>
+        <p:spPr>
+          <a:xfrm>
+            <a:off x="11100816" y="5577840"/>
+            <a:ext cx="822960" cy="822960"/>
+          </a:xfrm>
+          <a:prstGeom prst="ellipse">
+            <a:avLst/>
+          </a:prstGeom>
+          <a:solidFill>
+            <a:srgbClr val="FFFFFF">
+              <a:alpha val="94000"/>
+            </a:srgbClr>
+          </a:solidFill>
+          <a:ln w="15240">
+            <a:solidFill>
+              <a:srgbClr val="1F7A8C"/>
+            </a:solidFill>
+            <a:prstDash val="solid"/>
+          </a:ln>
+        </p:spPr>
+      </p:sp>
+      <p:sp>
+        <p:nvSpPr>
+          <p:cNvPr id="28" name="Shape 26"/>
+          <p:cNvSpPr/>
+          <p:nvPr/>
+        </p:nvSpPr>
+        <p:spPr>
+          <a:xfrm>
+            <a:off x="11247120" y="5724144"/>
+            <a:ext cx="530352" cy="530352"/>
+          </a:xfrm>
+          <a:prstGeom prst="ellipse">
+            <a:avLst/>
+          </a:prstGeom>
+          <a:solidFill>
+            <a:srgbClr val="FFFFFF">
+              <a:alpha val="0"/>
+            </a:srgbClr>
+          </a:solidFill>
+          <a:ln w="7620">
+            <a:solidFill>
+              <a:srgbClr val="D6DEE8"/>
+            </a:solidFill>
+            <a:prstDash val="solid"/>
+          </a:ln>
+        </p:spPr>
+      </p:sp>
     </p:spTree>
   </p:cSld>
   <p:clrMapOvr>
@@ -3159,8 +3242,8 @@
         </p:nvSpPr>
         <p:spPr>
           <a:xfrm>
-            <a:off x="7635240" y="6528816"/>
-            <a:ext cx="3977640" cy="164592"/>
+            <a:off x="6720840" y="6528816"/>
+            <a:ext cx="4069080" cy="164592"/>
           </a:xfrm>
           <a:prstGeom prst="rect">
             <a:avLst/>
@@ -4203,6 +4286,89 @@
             <a:endParaRPr lang="en-US" sz="800" dirty="0"/>
           </a:p>
         </p:txBody>
+      </p:sp>
+      <p:sp>
+        <p:nvSpPr>
+          <p:cNvPr id="37" name="Shape 35"/>
+          <p:cNvSpPr/>
+          <p:nvPr/>
+        </p:nvSpPr>
+        <p:spPr>
+          <a:xfrm>
+            <a:off x="11155680" y="5632704"/>
+            <a:ext cx="841248" cy="841248"/>
+          </a:xfrm>
+          <a:prstGeom prst="ellipse">
+            <a:avLst/>
+          </a:prstGeom>
+          <a:solidFill>
+            <a:srgbClr val="1B2430">
+              <a:alpha val="14000"/>
+            </a:srgbClr>
+          </a:solidFill>
+          <a:ln w="12700">
+            <a:solidFill>
+              <a:srgbClr val="1B2430">
+                <a:alpha val="0"/>
+              </a:srgbClr>
+            </a:solidFill>
+            <a:prstDash val="solid"/>
+          </a:ln>
+        </p:spPr>
+      </p:sp>
+      <p:sp>
+        <p:nvSpPr>
+          <p:cNvPr id="38" name="Shape 36"/>
+          <p:cNvSpPr/>
+          <p:nvPr/>
+        </p:nvSpPr>
+        <p:spPr>
+          <a:xfrm>
+            <a:off x="11100816" y="5577840"/>
+            <a:ext cx="822960" cy="822960"/>
+          </a:xfrm>
+          <a:prstGeom prst="ellipse">
+            <a:avLst/>
+          </a:prstGeom>
+          <a:solidFill>
+            <a:srgbClr val="FFFFFF">
+              <a:alpha val="94000"/>
+            </a:srgbClr>
+          </a:solidFill>
+          <a:ln w="15240">
+            <a:solidFill>
+              <a:srgbClr val="1F7A8C"/>
+            </a:solidFill>
+            <a:prstDash val="solid"/>
+          </a:ln>
+        </p:spPr>
+      </p:sp>
+      <p:sp>
+        <p:nvSpPr>
+          <p:cNvPr id="39" name="Shape 37"/>
+          <p:cNvSpPr/>
+          <p:nvPr/>
+        </p:nvSpPr>
+        <p:spPr>
+          <a:xfrm>
+            <a:off x="11247120" y="5724144"/>
+            <a:ext cx="530352" cy="530352"/>
+          </a:xfrm>
+          <a:prstGeom prst="ellipse">
+            <a:avLst/>
+          </a:prstGeom>
+          <a:solidFill>
+            <a:srgbClr val="FFFFFF">
+              <a:alpha val="0"/>
+            </a:srgbClr>
+          </a:solidFill>
+          <a:ln w="7620">
+            <a:solidFill>
+              <a:srgbClr val="D6DEE8"/>
+            </a:solidFill>
+            <a:prstDash val="solid"/>
+          </a:ln>
+        </p:spPr>
       </p:sp>
     </p:spTree>
   </p:cSld>
@@ -4386,8 +4552,8 @@
         </p:nvSpPr>
         <p:spPr>
           <a:xfrm>
-            <a:off x="7635240" y="6528816"/>
-            <a:ext cx="3977640" cy="164592"/>
+            <a:off x="6720840" y="6528816"/>
+            <a:ext cx="4069080" cy="164592"/>
           </a:xfrm>
           <a:prstGeom prst="rect">
             <a:avLst/>
@@ -5083,6 +5249,89 @@
             <a:endParaRPr lang="en-US" sz="670" dirty="0"/>
           </a:p>
         </p:txBody>
+      </p:sp>
+      <p:sp>
+        <p:nvSpPr>
+          <p:cNvPr id="28" name="Shape 26"/>
+          <p:cNvSpPr/>
+          <p:nvPr/>
+        </p:nvSpPr>
+        <p:spPr>
+          <a:xfrm>
+            <a:off x="11155680" y="5632704"/>
+            <a:ext cx="841248" cy="841248"/>
+          </a:xfrm>
+          <a:prstGeom prst="ellipse">
+            <a:avLst/>
+          </a:prstGeom>
+          <a:solidFill>
+            <a:srgbClr val="1B2430">
+              <a:alpha val="14000"/>
+            </a:srgbClr>
+          </a:solidFill>
+          <a:ln w="12700">
+            <a:solidFill>
+              <a:srgbClr val="1B2430">
+                <a:alpha val="0"/>
+              </a:srgbClr>
+            </a:solidFill>
+            <a:prstDash val="solid"/>
+          </a:ln>
+        </p:spPr>
+      </p:sp>
+      <p:sp>
+        <p:nvSpPr>
+          <p:cNvPr id="29" name="Shape 27"/>
+          <p:cNvSpPr/>
+          <p:nvPr/>
+        </p:nvSpPr>
+        <p:spPr>
+          <a:xfrm>
+            <a:off x="11100816" y="5577840"/>
+            <a:ext cx="822960" cy="822960"/>
+          </a:xfrm>
+          <a:prstGeom prst="ellipse">
+            <a:avLst/>
+          </a:prstGeom>
+          <a:solidFill>
+            <a:srgbClr val="FFFFFF">
+              <a:alpha val="94000"/>
+            </a:srgbClr>
+          </a:solidFill>
+          <a:ln w="15240">
+            <a:solidFill>
+              <a:srgbClr val="1F7A8C"/>
+            </a:solidFill>
+            <a:prstDash val="solid"/>
+          </a:ln>
+        </p:spPr>
+      </p:sp>
+      <p:sp>
+        <p:nvSpPr>
+          <p:cNvPr id="30" name="Shape 28"/>
+          <p:cNvSpPr/>
+          <p:nvPr/>
+        </p:nvSpPr>
+        <p:spPr>
+          <a:xfrm>
+            <a:off x="11247120" y="5724144"/>
+            <a:ext cx="530352" cy="530352"/>
+          </a:xfrm>
+          <a:prstGeom prst="ellipse">
+            <a:avLst/>
+          </a:prstGeom>
+          <a:solidFill>
+            <a:srgbClr val="FFFFFF">
+              <a:alpha val="0"/>
+            </a:srgbClr>
+          </a:solidFill>
+          <a:ln w="7620">
+            <a:solidFill>
+              <a:srgbClr val="D6DEE8"/>
+            </a:solidFill>
+            <a:prstDash val="solid"/>
+          </a:ln>
+        </p:spPr>
       </p:sp>
     </p:spTree>
   </p:cSld>
@@ -5266,8 +5515,8 @@
         </p:nvSpPr>
         <p:spPr>
           <a:xfrm>
-            <a:off x="7635240" y="6528816"/>
-            <a:ext cx="3977640" cy="164592"/>
+            <a:off x="6720840" y="6528816"/>
+            <a:ext cx="4069080" cy="164592"/>
           </a:xfrm>
           <a:prstGeom prst="rect">
             <a:avLst/>
@@ -6359,6 +6608,89 @@
             <a:endParaRPr lang="en-US" sz="710" dirty="0"/>
           </a:p>
         </p:txBody>
+      </p:sp>
+      <p:sp>
+        <p:nvSpPr>
+          <p:cNvPr id="34" name="Shape 32"/>
+          <p:cNvSpPr/>
+          <p:nvPr/>
+        </p:nvSpPr>
+        <p:spPr>
+          <a:xfrm>
+            <a:off x="11155680" y="5632704"/>
+            <a:ext cx="841248" cy="841248"/>
+          </a:xfrm>
+          <a:prstGeom prst="ellipse">
+            <a:avLst/>
+          </a:prstGeom>
+          <a:solidFill>
+            <a:srgbClr val="1B2430">
+              <a:alpha val="14000"/>
+            </a:srgbClr>
+          </a:solidFill>
+          <a:ln w="12700">
+            <a:solidFill>
+              <a:srgbClr val="1B2430">
+                <a:alpha val="0"/>
+              </a:srgbClr>
+            </a:solidFill>
+            <a:prstDash val="solid"/>
+          </a:ln>
+        </p:spPr>
+      </p:sp>
+      <p:sp>
+        <p:nvSpPr>
+          <p:cNvPr id="35" name="Shape 33"/>
+          <p:cNvSpPr/>
+          <p:nvPr/>
+        </p:nvSpPr>
+        <p:spPr>
+          <a:xfrm>
+            <a:off x="11100816" y="5577840"/>
+            <a:ext cx="822960" cy="822960"/>
+          </a:xfrm>
+          <a:prstGeom prst="ellipse">
+            <a:avLst/>
+          </a:prstGeom>
+          <a:solidFill>
+            <a:srgbClr val="FFFFFF">
+              <a:alpha val="94000"/>
+            </a:srgbClr>
+          </a:solidFill>
+          <a:ln w="15240">
+            <a:solidFill>
+              <a:srgbClr val="1F7A8C"/>
+            </a:solidFill>
+            <a:prstDash val="solid"/>
+          </a:ln>
+        </p:spPr>
+      </p:sp>
+      <p:sp>
+        <p:nvSpPr>
+          <p:cNvPr id="36" name="Shape 34"/>
+          <p:cNvSpPr/>
+          <p:nvPr/>
+        </p:nvSpPr>
+        <p:spPr>
+          <a:xfrm>
+            <a:off x="11247120" y="5724144"/>
+            <a:ext cx="530352" cy="530352"/>
+          </a:xfrm>
+          <a:prstGeom prst="ellipse">
+            <a:avLst/>
+          </a:prstGeom>
+          <a:solidFill>
+            <a:srgbClr val="FFFFFF">
+              <a:alpha val="0"/>
+            </a:srgbClr>
+          </a:solidFill>
+          <a:ln w="7620">
+            <a:solidFill>
+              <a:srgbClr val="D6DEE8"/>
+            </a:solidFill>
+            <a:prstDash val="solid"/>
+          </a:ln>
+        </p:spPr>
       </p:sp>
     </p:spTree>
   </p:cSld>
@@ -6542,8 +6874,8 @@
         </p:nvSpPr>
         <p:spPr>
           <a:xfrm>
-            <a:off x="7635240" y="6528816"/>
-            <a:ext cx="3977640" cy="164592"/>
+            <a:off x="6720840" y="6528816"/>
+            <a:ext cx="4069080" cy="164592"/>
           </a:xfrm>
           <a:prstGeom prst="rect">
             <a:avLst/>
@@ -8683,6 +9015,89 @@
             <a:endParaRPr lang="en-US" sz="640" dirty="0"/>
           </a:p>
         </p:txBody>
+      </p:sp>
+      <p:sp>
+        <p:nvSpPr>
+          <p:cNvPr id="62" name="Shape 60"/>
+          <p:cNvSpPr/>
+          <p:nvPr/>
+        </p:nvSpPr>
+        <p:spPr>
+          <a:xfrm>
+            <a:off x="11155680" y="5632704"/>
+            <a:ext cx="841248" cy="841248"/>
+          </a:xfrm>
+          <a:prstGeom prst="ellipse">
+            <a:avLst/>
+          </a:prstGeom>
+          <a:solidFill>
+            <a:srgbClr val="1B2430">
+              <a:alpha val="14000"/>
+            </a:srgbClr>
+          </a:solidFill>
+          <a:ln w="12700">
+            <a:solidFill>
+              <a:srgbClr val="1B2430">
+                <a:alpha val="0"/>
+              </a:srgbClr>
+            </a:solidFill>
+            <a:prstDash val="solid"/>
+          </a:ln>
+        </p:spPr>
+      </p:sp>
+      <p:sp>
+        <p:nvSpPr>
+          <p:cNvPr id="63" name="Shape 61"/>
+          <p:cNvSpPr/>
+          <p:nvPr/>
+        </p:nvSpPr>
+        <p:spPr>
+          <a:xfrm>
+            <a:off x="11100816" y="5577840"/>
+            <a:ext cx="822960" cy="822960"/>
+          </a:xfrm>
+          <a:prstGeom prst="ellipse">
+            <a:avLst/>
+          </a:prstGeom>
+          <a:solidFill>
+            <a:srgbClr val="FFFFFF">
+              <a:alpha val="94000"/>
+            </a:srgbClr>
+          </a:solidFill>
+          <a:ln w="15240">
+            <a:solidFill>
+              <a:srgbClr val="1F7A8C"/>
+            </a:solidFill>
+            <a:prstDash val="solid"/>
+          </a:ln>
+        </p:spPr>
+      </p:sp>
+      <p:sp>
+        <p:nvSpPr>
+          <p:cNvPr id="64" name="Shape 62"/>
+          <p:cNvSpPr/>
+          <p:nvPr/>
+        </p:nvSpPr>
+        <p:spPr>
+          <a:xfrm>
+            <a:off x="11247120" y="5724144"/>
+            <a:ext cx="530352" cy="530352"/>
+          </a:xfrm>
+          <a:prstGeom prst="ellipse">
+            <a:avLst/>
+          </a:prstGeom>
+          <a:solidFill>
+            <a:srgbClr val="FFFFFF">
+              <a:alpha val="0"/>
+            </a:srgbClr>
+          </a:solidFill>
+          <a:ln w="7620">
+            <a:solidFill>
+              <a:srgbClr val="D6DEE8"/>
+            </a:solidFill>
+            <a:prstDash val="solid"/>
+          </a:ln>
+        </p:spPr>
       </p:sp>
     </p:spTree>
   </p:cSld>
@@ -8866,8 +9281,8 @@
         </p:nvSpPr>
         <p:spPr>
           <a:xfrm>
-            <a:off x="7635240" y="6528816"/>
-            <a:ext cx="3977640" cy="164592"/>
+            <a:off x="6720840" y="6528816"/>
+            <a:ext cx="4069080" cy="164592"/>
           </a:xfrm>
           <a:prstGeom prst="rect">
             <a:avLst/>
@@ -10113,6 +10528,89 @@
             <a:endParaRPr lang="en-US" sz="630" dirty="0"/>
           </a:p>
         </p:txBody>
+      </p:sp>
+      <p:sp>
+        <p:nvSpPr>
+          <p:cNvPr id="39" name="Shape 37"/>
+          <p:cNvSpPr/>
+          <p:nvPr/>
+        </p:nvSpPr>
+        <p:spPr>
+          <a:xfrm>
+            <a:off x="11155680" y="5632704"/>
+            <a:ext cx="841248" cy="841248"/>
+          </a:xfrm>
+          <a:prstGeom prst="ellipse">
+            <a:avLst/>
+          </a:prstGeom>
+          <a:solidFill>
+            <a:srgbClr val="1B2430">
+              <a:alpha val="14000"/>
+            </a:srgbClr>
+          </a:solidFill>
+          <a:ln w="12700">
+            <a:solidFill>
+              <a:srgbClr val="1B2430">
+                <a:alpha val="0"/>
+              </a:srgbClr>
+            </a:solidFill>
+            <a:prstDash val="solid"/>
+          </a:ln>
+        </p:spPr>
+      </p:sp>
+      <p:sp>
+        <p:nvSpPr>
+          <p:cNvPr id="40" name="Shape 38"/>
+          <p:cNvSpPr/>
+          <p:nvPr/>
+        </p:nvSpPr>
+        <p:spPr>
+          <a:xfrm>
+            <a:off x="11100816" y="5577840"/>
+            <a:ext cx="822960" cy="822960"/>
+          </a:xfrm>
+          <a:prstGeom prst="ellipse">
+            <a:avLst/>
+          </a:prstGeom>
+          <a:solidFill>
+            <a:srgbClr val="FFFFFF">
+              <a:alpha val="94000"/>
+            </a:srgbClr>
+          </a:solidFill>
+          <a:ln w="15240">
+            <a:solidFill>
+              <a:srgbClr val="1F7A8C"/>
+            </a:solidFill>
+            <a:prstDash val="solid"/>
+          </a:ln>
+        </p:spPr>
+      </p:sp>
+      <p:sp>
+        <p:nvSpPr>
+          <p:cNvPr id="41" name="Shape 39"/>
+          <p:cNvSpPr/>
+          <p:nvPr/>
+        </p:nvSpPr>
+        <p:spPr>
+          <a:xfrm>
+            <a:off x="11247120" y="5724144"/>
+            <a:ext cx="530352" cy="530352"/>
+          </a:xfrm>
+          <a:prstGeom prst="ellipse">
+            <a:avLst/>
+          </a:prstGeom>
+          <a:solidFill>
+            <a:srgbClr val="FFFFFF">
+              <a:alpha val="0"/>
+            </a:srgbClr>
+          </a:solidFill>
+          <a:ln w="7620">
+            <a:solidFill>
+              <a:srgbClr val="D6DEE8"/>
+            </a:solidFill>
+            <a:prstDash val="solid"/>
+          </a:ln>
+        </p:spPr>
       </p:sp>
     </p:spTree>
   </p:cSld>
@@ -10296,8 +10794,8 @@
         </p:nvSpPr>
         <p:spPr>
           <a:xfrm>
-            <a:off x="7635240" y="6528816"/>
-            <a:ext cx="3977640" cy="164592"/>
+            <a:off x="6720840" y="6528816"/>
+            <a:ext cx="4069080" cy="164592"/>
           </a:xfrm>
           <a:prstGeom prst="rect">
             <a:avLst/>
@@ -11828,6 +12326,89 @@
             <a:endParaRPr lang="en-US" sz="600" dirty="0"/>
           </a:p>
         </p:txBody>
+      </p:sp>
+      <p:sp>
+        <p:nvSpPr>
+          <p:cNvPr id="49" name="Shape 47"/>
+          <p:cNvSpPr/>
+          <p:nvPr/>
+        </p:nvSpPr>
+        <p:spPr>
+          <a:xfrm>
+            <a:off x="11155680" y="5632704"/>
+            <a:ext cx="841248" cy="841248"/>
+          </a:xfrm>
+          <a:prstGeom prst="ellipse">
+            <a:avLst/>
+          </a:prstGeom>
+          <a:solidFill>
+            <a:srgbClr val="1B2430">
+              <a:alpha val="14000"/>
+            </a:srgbClr>
+          </a:solidFill>
+          <a:ln w="12700">
+            <a:solidFill>
+              <a:srgbClr val="1B2430">
+                <a:alpha val="0"/>
+              </a:srgbClr>
+            </a:solidFill>
+            <a:prstDash val="solid"/>
+          </a:ln>
+        </p:spPr>
+      </p:sp>
+      <p:sp>
+        <p:nvSpPr>
+          <p:cNvPr id="50" name="Shape 48"/>
+          <p:cNvSpPr/>
+          <p:nvPr/>
+        </p:nvSpPr>
+        <p:spPr>
+          <a:xfrm>
+            <a:off x="11100816" y="5577840"/>
+            <a:ext cx="822960" cy="822960"/>
+          </a:xfrm>
+          <a:prstGeom prst="ellipse">
+            <a:avLst/>
+          </a:prstGeom>
+          <a:solidFill>
+            <a:srgbClr val="FFFFFF">
+              <a:alpha val="94000"/>
+            </a:srgbClr>
+          </a:solidFill>
+          <a:ln w="15240">
+            <a:solidFill>
+              <a:srgbClr val="1F7A8C"/>
+            </a:solidFill>
+            <a:prstDash val="solid"/>
+          </a:ln>
+        </p:spPr>
+      </p:sp>
+      <p:sp>
+        <p:nvSpPr>
+          <p:cNvPr id="51" name="Shape 49"/>
+          <p:cNvSpPr/>
+          <p:nvPr/>
+        </p:nvSpPr>
+        <p:spPr>
+          <a:xfrm>
+            <a:off x="11247120" y="5724144"/>
+            <a:ext cx="530352" cy="530352"/>
+          </a:xfrm>
+          <a:prstGeom prst="ellipse">
+            <a:avLst/>
+          </a:prstGeom>
+          <a:solidFill>
+            <a:srgbClr val="FFFFFF">
+              <a:alpha val="0"/>
+            </a:srgbClr>
+          </a:solidFill>
+          <a:ln w="7620">
+            <a:solidFill>
+              <a:srgbClr val="D6DEE8"/>
+            </a:solidFill>
+            <a:prstDash val="solid"/>
+          </a:ln>
+        </p:spPr>
       </p:sp>
     </p:spTree>
   </p:cSld>
@@ -12011,8 +12592,8 @@
         </p:nvSpPr>
         <p:spPr>
           <a:xfrm>
-            <a:off x="7635240" y="6528816"/>
-            <a:ext cx="3977640" cy="164592"/>
+            <a:off x="6720840" y="6528816"/>
+            <a:ext cx="4069080" cy="164592"/>
           </a:xfrm>
           <a:prstGeom prst="rect">
             <a:avLst/>
@@ -12609,6 +13190,89 @@
             <a:endParaRPr lang="en-US" sz="680" dirty="0"/>
           </a:p>
         </p:txBody>
+      </p:sp>
+      <p:sp>
+        <p:nvSpPr>
+          <p:cNvPr id="24" name="Shape 22"/>
+          <p:cNvSpPr/>
+          <p:nvPr/>
+        </p:nvSpPr>
+        <p:spPr>
+          <a:xfrm>
+            <a:off x="11155680" y="5632704"/>
+            <a:ext cx="841248" cy="841248"/>
+          </a:xfrm>
+          <a:prstGeom prst="ellipse">
+            <a:avLst/>
+          </a:prstGeom>
+          <a:solidFill>
+            <a:srgbClr val="1B2430">
+              <a:alpha val="14000"/>
+            </a:srgbClr>
+          </a:solidFill>
+          <a:ln w="12700">
+            <a:solidFill>
+              <a:srgbClr val="1B2430">
+                <a:alpha val="0"/>
+              </a:srgbClr>
+            </a:solidFill>
+            <a:prstDash val="solid"/>
+          </a:ln>
+        </p:spPr>
+      </p:sp>
+      <p:sp>
+        <p:nvSpPr>
+          <p:cNvPr id="25" name="Shape 23"/>
+          <p:cNvSpPr/>
+          <p:nvPr/>
+        </p:nvSpPr>
+        <p:spPr>
+          <a:xfrm>
+            <a:off x="11100816" y="5577840"/>
+            <a:ext cx="822960" cy="822960"/>
+          </a:xfrm>
+          <a:prstGeom prst="ellipse">
+            <a:avLst/>
+          </a:prstGeom>
+          <a:solidFill>
+            <a:srgbClr val="FFFFFF">
+              <a:alpha val="94000"/>
+            </a:srgbClr>
+          </a:solidFill>
+          <a:ln w="15240">
+            <a:solidFill>
+              <a:srgbClr val="1F7A8C"/>
+            </a:solidFill>
+            <a:prstDash val="solid"/>
+          </a:ln>
+        </p:spPr>
+      </p:sp>
+      <p:sp>
+        <p:nvSpPr>
+          <p:cNvPr id="26" name="Shape 24"/>
+          <p:cNvSpPr/>
+          <p:nvPr/>
+        </p:nvSpPr>
+        <p:spPr>
+          <a:xfrm>
+            <a:off x="11247120" y="5724144"/>
+            <a:ext cx="530352" cy="530352"/>
+          </a:xfrm>
+          <a:prstGeom prst="ellipse">
+            <a:avLst/>
+          </a:prstGeom>
+          <a:solidFill>
+            <a:srgbClr val="FFFFFF">
+              <a:alpha val="0"/>
+            </a:srgbClr>
+          </a:solidFill>
+          <a:ln w="7620">
+            <a:solidFill>
+              <a:srgbClr val="D6DEE8"/>
+            </a:solidFill>
+            <a:prstDash val="solid"/>
+          </a:ln>
+        </p:spPr>
       </p:sp>
     </p:spTree>
   </p:cSld>
@@ -12792,8 +13456,8 @@
         </p:nvSpPr>
         <p:spPr>
           <a:xfrm>
-            <a:off x="7635240" y="6528816"/>
-            <a:ext cx="3977640" cy="164592"/>
+            <a:off x="6720840" y="6528816"/>
+            <a:ext cx="4069080" cy="164592"/>
           </a:xfrm>
           <a:prstGeom prst="rect">
             <a:avLst/>
@@ -13287,6 +13951,89 @@
             <a:endParaRPr lang="en-US" sz="650" dirty="0"/>
           </a:p>
         </p:txBody>
+      </p:sp>
+      <p:sp>
+        <p:nvSpPr>
+          <p:cNvPr id="18" name="Shape 16"/>
+          <p:cNvSpPr/>
+          <p:nvPr/>
+        </p:nvSpPr>
+        <p:spPr>
+          <a:xfrm>
+            <a:off x="11155680" y="5632704"/>
+            <a:ext cx="841248" cy="841248"/>
+          </a:xfrm>
+          <a:prstGeom prst="ellipse">
+            <a:avLst/>
+          </a:prstGeom>
+          <a:solidFill>
+            <a:srgbClr val="1B2430">
+              <a:alpha val="14000"/>
+            </a:srgbClr>
+          </a:solidFill>
+          <a:ln w="12700">
+            <a:solidFill>
+              <a:srgbClr val="1B2430">
+                <a:alpha val="0"/>
+              </a:srgbClr>
+            </a:solidFill>
+            <a:prstDash val="solid"/>
+          </a:ln>
+        </p:spPr>
+      </p:sp>
+      <p:sp>
+        <p:nvSpPr>
+          <p:cNvPr id="19" name="Shape 17"/>
+          <p:cNvSpPr/>
+          <p:nvPr/>
+        </p:nvSpPr>
+        <p:spPr>
+          <a:xfrm>
+            <a:off x="11100816" y="5577840"/>
+            <a:ext cx="822960" cy="822960"/>
+          </a:xfrm>
+          <a:prstGeom prst="ellipse">
+            <a:avLst/>
+          </a:prstGeom>
+          <a:solidFill>
+            <a:srgbClr val="FFFFFF">
+              <a:alpha val="94000"/>
+            </a:srgbClr>
+          </a:solidFill>
+          <a:ln w="15240">
+            <a:solidFill>
+              <a:srgbClr val="1F7A8C"/>
+            </a:solidFill>
+            <a:prstDash val="solid"/>
+          </a:ln>
+        </p:spPr>
+      </p:sp>
+      <p:sp>
+        <p:nvSpPr>
+          <p:cNvPr id="20" name="Shape 18"/>
+          <p:cNvSpPr/>
+          <p:nvPr/>
+        </p:nvSpPr>
+        <p:spPr>
+          <a:xfrm>
+            <a:off x="11247120" y="5724144"/>
+            <a:ext cx="530352" cy="530352"/>
+          </a:xfrm>
+          <a:prstGeom prst="ellipse">
+            <a:avLst/>
+          </a:prstGeom>
+          <a:solidFill>
+            <a:srgbClr val="FFFFFF">
+              <a:alpha val="0"/>
+            </a:srgbClr>
+          </a:solidFill>
+          <a:ln w="7620">
+            <a:solidFill>
+              <a:srgbClr val="D6DEE8"/>
+            </a:solidFill>
+            <a:prstDash val="solid"/>
+          </a:ln>
+        </p:spPr>
       </p:sp>
     </p:spTree>
   </p:cSld>
@@ -13470,8 +14217,8 @@
         </p:nvSpPr>
         <p:spPr>
           <a:xfrm>
-            <a:off x="7635240" y="6528816"/>
-            <a:ext cx="3977640" cy="164592"/>
+            <a:off x="6720840" y="6528816"/>
+            <a:ext cx="4069080" cy="164592"/>
           </a:xfrm>
           <a:prstGeom prst="rect">
             <a:avLst/>
@@ -14090,6 +14837,89 @@
             <a:endParaRPr lang="en-US" sz="640" dirty="0"/>
           </a:p>
         </p:txBody>
+      </p:sp>
+      <p:sp>
+        <p:nvSpPr>
+          <p:cNvPr id="27" name="Shape 25"/>
+          <p:cNvSpPr/>
+          <p:nvPr/>
+        </p:nvSpPr>
+        <p:spPr>
+          <a:xfrm>
+            <a:off x="11155680" y="5632704"/>
+            <a:ext cx="841248" cy="841248"/>
+          </a:xfrm>
+          <a:prstGeom prst="ellipse">
+            <a:avLst/>
+          </a:prstGeom>
+          <a:solidFill>
+            <a:srgbClr val="1B2430">
+              <a:alpha val="14000"/>
+            </a:srgbClr>
+          </a:solidFill>
+          <a:ln w="12700">
+            <a:solidFill>
+              <a:srgbClr val="1B2430">
+                <a:alpha val="0"/>
+              </a:srgbClr>
+            </a:solidFill>
+            <a:prstDash val="solid"/>
+          </a:ln>
+        </p:spPr>
+      </p:sp>
+      <p:sp>
+        <p:nvSpPr>
+          <p:cNvPr id="28" name="Shape 26"/>
+          <p:cNvSpPr/>
+          <p:nvPr/>
+        </p:nvSpPr>
+        <p:spPr>
+          <a:xfrm>
+            <a:off x="11100816" y="5577840"/>
+            <a:ext cx="822960" cy="822960"/>
+          </a:xfrm>
+          <a:prstGeom prst="ellipse">
+            <a:avLst/>
+          </a:prstGeom>
+          <a:solidFill>
+            <a:srgbClr val="FFFFFF">
+              <a:alpha val="94000"/>
+            </a:srgbClr>
+          </a:solidFill>
+          <a:ln w="15240">
+            <a:solidFill>
+              <a:srgbClr val="1F7A8C"/>
+            </a:solidFill>
+            <a:prstDash val="solid"/>
+          </a:ln>
+        </p:spPr>
+      </p:sp>
+      <p:sp>
+        <p:nvSpPr>
+          <p:cNvPr id="29" name="Shape 27"/>
+          <p:cNvSpPr/>
+          <p:nvPr/>
+        </p:nvSpPr>
+        <p:spPr>
+          <a:xfrm>
+            <a:off x="11247120" y="5724144"/>
+            <a:ext cx="530352" cy="530352"/>
+          </a:xfrm>
+          <a:prstGeom prst="ellipse">
+            <a:avLst/>
+          </a:prstGeom>
+          <a:solidFill>
+            <a:srgbClr val="FFFFFF">
+              <a:alpha val="0"/>
+            </a:srgbClr>
+          </a:solidFill>
+          <a:ln w="7620">
+            <a:solidFill>
+              <a:srgbClr val="D6DEE8"/>
+            </a:solidFill>
+            <a:prstDash val="solid"/>
+          </a:ln>
+        </p:spPr>
       </p:sp>
     </p:spTree>
   </p:cSld>
@@ -14273,8 +15103,8 @@
         </p:nvSpPr>
         <p:spPr>
           <a:xfrm>
-            <a:off x="7635240" y="6528816"/>
-            <a:ext cx="3977640" cy="164592"/>
+            <a:off x="6720840" y="6528816"/>
+            <a:ext cx="4069080" cy="164592"/>
           </a:xfrm>
           <a:prstGeom prst="rect">
             <a:avLst/>
@@ -15090,6 +15920,89 @@
             <a:endParaRPr lang="en-US" sz="690" dirty="0"/>
           </a:p>
         </p:txBody>
+      </p:sp>
+      <p:sp>
+        <p:nvSpPr>
+          <p:cNvPr id="28" name="Shape 26"/>
+          <p:cNvSpPr/>
+          <p:nvPr/>
+        </p:nvSpPr>
+        <p:spPr>
+          <a:xfrm>
+            <a:off x="11155680" y="5632704"/>
+            <a:ext cx="841248" cy="841248"/>
+          </a:xfrm>
+          <a:prstGeom prst="ellipse">
+            <a:avLst/>
+          </a:prstGeom>
+          <a:solidFill>
+            <a:srgbClr val="1B2430">
+              <a:alpha val="14000"/>
+            </a:srgbClr>
+          </a:solidFill>
+          <a:ln w="12700">
+            <a:solidFill>
+              <a:srgbClr val="1B2430">
+                <a:alpha val="0"/>
+              </a:srgbClr>
+            </a:solidFill>
+            <a:prstDash val="solid"/>
+          </a:ln>
+        </p:spPr>
+      </p:sp>
+      <p:sp>
+        <p:nvSpPr>
+          <p:cNvPr id="29" name="Shape 27"/>
+          <p:cNvSpPr/>
+          <p:nvPr/>
+        </p:nvSpPr>
+        <p:spPr>
+          <a:xfrm>
+            <a:off x="11100816" y="5577840"/>
+            <a:ext cx="822960" cy="822960"/>
+          </a:xfrm>
+          <a:prstGeom prst="ellipse">
+            <a:avLst/>
+          </a:prstGeom>
+          <a:solidFill>
+            <a:srgbClr val="FFFFFF">
+              <a:alpha val="94000"/>
+            </a:srgbClr>
+          </a:solidFill>
+          <a:ln w="15240">
+            <a:solidFill>
+              <a:srgbClr val="1F7A8C"/>
+            </a:solidFill>
+            <a:prstDash val="solid"/>
+          </a:ln>
+        </p:spPr>
+      </p:sp>
+      <p:sp>
+        <p:nvSpPr>
+          <p:cNvPr id="30" name="Shape 28"/>
+          <p:cNvSpPr/>
+          <p:nvPr/>
+        </p:nvSpPr>
+        <p:spPr>
+          <a:xfrm>
+            <a:off x="11247120" y="5724144"/>
+            <a:ext cx="530352" cy="530352"/>
+          </a:xfrm>
+          <a:prstGeom prst="ellipse">
+            <a:avLst/>
+          </a:prstGeom>
+          <a:solidFill>
+            <a:srgbClr val="FFFFFF">
+              <a:alpha val="0"/>
+            </a:srgbClr>
+          </a:solidFill>
+          <a:ln w="7620">
+            <a:solidFill>
+              <a:srgbClr val="D6DEE8"/>
+            </a:solidFill>
+            <a:prstDash val="solid"/>
+          </a:ln>
+        </p:spPr>
       </p:sp>
     </p:spTree>
   </p:cSld>
@@ -15273,8 +16186,8 @@
         </p:nvSpPr>
         <p:spPr>
           <a:xfrm>
-            <a:off x="7635240" y="6528816"/>
-            <a:ext cx="3977640" cy="164592"/>
+            <a:off x="6720840" y="6528816"/>
+            <a:ext cx="4069080" cy="164592"/>
           </a:xfrm>
           <a:prstGeom prst="rect">
             <a:avLst/>
@@ -16345,6 +17258,89 @@
             <a:endParaRPr lang="en-US" sz="620" dirty="0"/>
           </a:p>
         </p:txBody>
+      </p:sp>
+      <p:sp>
+        <p:nvSpPr>
+          <p:cNvPr id="33" name="Shape 31"/>
+          <p:cNvSpPr/>
+          <p:nvPr/>
+        </p:nvSpPr>
+        <p:spPr>
+          <a:xfrm>
+            <a:off x="11155680" y="5632704"/>
+            <a:ext cx="841248" cy="841248"/>
+          </a:xfrm>
+          <a:prstGeom prst="ellipse">
+            <a:avLst/>
+          </a:prstGeom>
+          <a:solidFill>
+            <a:srgbClr val="1B2430">
+              <a:alpha val="14000"/>
+            </a:srgbClr>
+          </a:solidFill>
+          <a:ln w="12700">
+            <a:solidFill>
+              <a:srgbClr val="1B2430">
+                <a:alpha val="0"/>
+              </a:srgbClr>
+            </a:solidFill>
+            <a:prstDash val="solid"/>
+          </a:ln>
+        </p:spPr>
+      </p:sp>
+      <p:sp>
+        <p:nvSpPr>
+          <p:cNvPr id="34" name="Shape 32"/>
+          <p:cNvSpPr/>
+          <p:nvPr/>
+        </p:nvSpPr>
+        <p:spPr>
+          <a:xfrm>
+            <a:off x="11100816" y="5577840"/>
+            <a:ext cx="822960" cy="822960"/>
+          </a:xfrm>
+          <a:prstGeom prst="ellipse">
+            <a:avLst/>
+          </a:prstGeom>
+          <a:solidFill>
+            <a:srgbClr val="FFFFFF">
+              <a:alpha val="94000"/>
+            </a:srgbClr>
+          </a:solidFill>
+          <a:ln w="15240">
+            <a:solidFill>
+              <a:srgbClr val="1F7A8C"/>
+            </a:solidFill>
+            <a:prstDash val="solid"/>
+          </a:ln>
+        </p:spPr>
+      </p:sp>
+      <p:sp>
+        <p:nvSpPr>
+          <p:cNvPr id="35" name="Shape 33"/>
+          <p:cNvSpPr/>
+          <p:nvPr/>
+        </p:nvSpPr>
+        <p:spPr>
+          <a:xfrm>
+            <a:off x="11247120" y="5724144"/>
+            <a:ext cx="530352" cy="530352"/>
+          </a:xfrm>
+          <a:prstGeom prst="ellipse">
+            <a:avLst/>
+          </a:prstGeom>
+          <a:solidFill>
+            <a:srgbClr val="FFFFFF">
+              <a:alpha val="0"/>
+            </a:srgbClr>
+          </a:solidFill>
+          <a:ln w="7620">
+            <a:solidFill>
+              <a:srgbClr val="D6DEE8"/>
+            </a:solidFill>
+            <a:prstDash val="solid"/>
+          </a:ln>
+        </p:spPr>
       </p:sp>
     </p:spTree>
   </p:cSld>
@@ -16528,8 +17524,8 @@
         </p:nvSpPr>
         <p:spPr>
           <a:xfrm>
-            <a:off x="7635240" y="6528816"/>
-            <a:ext cx="3977640" cy="164592"/>
+            <a:off x="6720840" y="6528816"/>
+            <a:ext cx="4069080" cy="164592"/>
           </a:xfrm>
           <a:prstGeom prst="rect">
             <a:avLst/>
@@ -17276,6 +18272,89 @@
             <a:endParaRPr lang="en-US" sz="730" dirty="0"/>
           </a:p>
         </p:txBody>
+      </p:sp>
+      <p:sp>
+        <p:nvSpPr>
+          <p:cNvPr id="25" name="Shape 23"/>
+          <p:cNvSpPr/>
+          <p:nvPr/>
+        </p:nvSpPr>
+        <p:spPr>
+          <a:xfrm>
+            <a:off x="11155680" y="5632704"/>
+            <a:ext cx="841248" cy="841248"/>
+          </a:xfrm>
+          <a:prstGeom prst="ellipse">
+            <a:avLst/>
+          </a:prstGeom>
+          <a:solidFill>
+            <a:srgbClr val="1B2430">
+              <a:alpha val="14000"/>
+            </a:srgbClr>
+          </a:solidFill>
+          <a:ln w="12700">
+            <a:solidFill>
+              <a:srgbClr val="1B2430">
+                <a:alpha val="0"/>
+              </a:srgbClr>
+            </a:solidFill>
+            <a:prstDash val="solid"/>
+          </a:ln>
+        </p:spPr>
+      </p:sp>
+      <p:sp>
+        <p:nvSpPr>
+          <p:cNvPr id="26" name="Shape 24"/>
+          <p:cNvSpPr/>
+          <p:nvPr/>
+        </p:nvSpPr>
+        <p:spPr>
+          <a:xfrm>
+            <a:off x="11100816" y="5577840"/>
+            <a:ext cx="822960" cy="822960"/>
+          </a:xfrm>
+          <a:prstGeom prst="ellipse">
+            <a:avLst/>
+          </a:prstGeom>
+          <a:solidFill>
+            <a:srgbClr val="FFFFFF">
+              <a:alpha val="94000"/>
+            </a:srgbClr>
+          </a:solidFill>
+          <a:ln w="15240">
+            <a:solidFill>
+              <a:srgbClr val="1F7A8C"/>
+            </a:solidFill>
+            <a:prstDash val="solid"/>
+          </a:ln>
+        </p:spPr>
+      </p:sp>
+      <p:sp>
+        <p:nvSpPr>
+          <p:cNvPr id="27" name="Shape 25"/>
+          <p:cNvSpPr/>
+          <p:nvPr/>
+        </p:nvSpPr>
+        <p:spPr>
+          <a:xfrm>
+            <a:off x="11247120" y="5724144"/>
+            <a:ext cx="530352" cy="530352"/>
+          </a:xfrm>
+          <a:prstGeom prst="ellipse">
+            <a:avLst/>
+          </a:prstGeom>
+          <a:solidFill>
+            <a:srgbClr val="FFFFFF">
+              <a:alpha val="0"/>
+            </a:srgbClr>
+          </a:solidFill>
+          <a:ln w="7620">
+            <a:solidFill>
+              <a:srgbClr val="D6DEE8"/>
+            </a:solidFill>
+            <a:prstDash val="solid"/>
+          </a:ln>
+        </p:spPr>
       </p:sp>
     </p:spTree>
   </p:cSld>
@@ -17459,8 +18538,8 @@
         </p:nvSpPr>
         <p:spPr>
           <a:xfrm>
-            <a:off x="7635240" y="6528816"/>
-            <a:ext cx="3977640" cy="164592"/>
+            <a:off x="6720840" y="6528816"/>
+            <a:ext cx="4069080" cy="164592"/>
           </a:xfrm>
           <a:prstGeom prst="rect">
             <a:avLst/>
@@ -18872,6 +19951,89 @@
             <a:endParaRPr lang="en-US" sz="710" dirty="0"/>
           </a:p>
         </p:txBody>
+      </p:sp>
+      <p:sp>
+        <p:nvSpPr>
+          <p:cNvPr id="47" name="Shape 45"/>
+          <p:cNvSpPr/>
+          <p:nvPr/>
+        </p:nvSpPr>
+        <p:spPr>
+          <a:xfrm>
+            <a:off x="11155680" y="5632704"/>
+            <a:ext cx="841248" cy="841248"/>
+          </a:xfrm>
+          <a:prstGeom prst="ellipse">
+            <a:avLst/>
+          </a:prstGeom>
+          <a:solidFill>
+            <a:srgbClr val="1B2430">
+              <a:alpha val="14000"/>
+            </a:srgbClr>
+          </a:solidFill>
+          <a:ln w="12700">
+            <a:solidFill>
+              <a:srgbClr val="1B2430">
+                <a:alpha val="0"/>
+              </a:srgbClr>
+            </a:solidFill>
+            <a:prstDash val="solid"/>
+          </a:ln>
+        </p:spPr>
+      </p:sp>
+      <p:sp>
+        <p:nvSpPr>
+          <p:cNvPr id="48" name="Shape 46"/>
+          <p:cNvSpPr/>
+          <p:nvPr/>
+        </p:nvSpPr>
+        <p:spPr>
+          <a:xfrm>
+            <a:off x="11100816" y="5577840"/>
+            <a:ext cx="822960" cy="822960"/>
+          </a:xfrm>
+          <a:prstGeom prst="ellipse">
+            <a:avLst/>
+          </a:prstGeom>
+          <a:solidFill>
+            <a:srgbClr val="FFFFFF">
+              <a:alpha val="94000"/>
+            </a:srgbClr>
+          </a:solidFill>
+          <a:ln w="15240">
+            <a:solidFill>
+              <a:srgbClr val="1F7A8C"/>
+            </a:solidFill>
+            <a:prstDash val="solid"/>
+          </a:ln>
+        </p:spPr>
+      </p:sp>
+      <p:sp>
+        <p:nvSpPr>
+          <p:cNvPr id="49" name="Shape 47"/>
+          <p:cNvSpPr/>
+          <p:nvPr/>
+        </p:nvSpPr>
+        <p:spPr>
+          <a:xfrm>
+            <a:off x="11247120" y="5724144"/>
+            <a:ext cx="530352" cy="530352"/>
+          </a:xfrm>
+          <a:prstGeom prst="ellipse">
+            <a:avLst/>
+          </a:prstGeom>
+          <a:solidFill>
+            <a:srgbClr val="FFFFFF">
+              <a:alpha val="0"/>
+            </a:srgbClr>
+          </a:solidFill>
+          <a:ln w="7620">
+            <a:solidFill>
+              <a:srgbClr val="D6DEE8"/>
+            </a:solidFill>
+            <a:prstDash val="solid"/>
+          </a:ln>
+        </p:spPr>
       </p:sp>
     </p:spTree>
   </p:cSld>
@@ -19055,8 +20217,8 @@
         </p:nvSpPr>
         <p:spPr>
           <a:xfrm>
-            <a:off x="7635240" y="6528816"/>
-            <a:ext cx="3977640" cy="164592"/>
+            <a:off x="6720840" y="6528816"/>
+            <a:ext cx="4069080" cy="164592"/>
           </a:xfrm>
           <a:prstGeom prst="rect">
             <a:avLst/>
@@ -19761,6 +20923,89 @@
             <a:endParaRPr lang="en-US" sz="650" dirty="0"/>
           </a:p>
         </p:txBody>
+      </p:sp>
+      <p:sp>
+        <p:nvSpPr>
+          <p:cNvPr id="27" name="Shape 25"/>
+          <p:cNvSpPr/>
+          <p:nvPr/>
+        </p:nvSpPr>
+        <p:spPr>
+          <a:xfrm>
+            <a:off x="11155680" y="5632704"/>
+            <a:ext cx="841248" cy="841248"/>
+          </a:xfrm>
+          <a:prstGeom prst="ellipse">
+            <a:avLst/>
+          </a:prstGeom>
+          <a:solidFill>
+            <a:srgbClr val="1B2430">
+              <a:alpha val="14000"/>
+            </a:srgbClr>
+          </a:solidFill>
+          <a:ln w="12700">
+            <a:solidFill>
+              <a:srgbClr val="1B2430">
+                <a:alpha val="0"/>
+              </a:srgbClr>
+            </a:solidFill>
+            <a:prstDash val="solid"/>
+          </a:ln>
+        </p:spPr>
+      </p:sp>
+      <p:sp>
+        <p:nvSpPr>
+          <p:cNvPr id="28" name="Shape 26"/>
+          <p:cNvSpPr/>
+          <p:nvPr/>
+        </p:nvSpPr>
+        <p:spPr>
+          <a:xfrm>
+            <a:off x="11100816" y="5577840"/>
+            <a:ext cx="822960" cy="822960"/>
+          </a:xfrm>
+          <a:prstGeom prst="ellipse">
+            <a:avLst/>
+          </a:prstGeom>
+          <a:solidFill>
+            <a:srgbClr val="FFFFFF">
+              <a:alpha val="94000"/>
+            </a:srgbClr>
+          </a:solidFill>
+          <a:ln w="15240">
+            <a:solidFill>
+              <a:srgbClr val="1F7A8C"/>
+            </a:solidFill>
+            <a:prstDash val="solid"/>
+          </a:ln>
+        </p:spPr>
+      </p:sp>
+      <p:sp>
+        <p:nvSpPr>
+          <p:cNvPr id="29" name="Shape 27"/>
+          <p:cNvSpPr/>
+          <p:nvPr/>
+        </p:nvSpPr>
+        <p:spPr>
+          <a:xfrm>
+            <a:off x="11247120" y="5724144"/>
+            <a:ext cx="530352" cy="530352"/>
+          </a:xfrm>
+          <a:prstGeom prst="ellipse">
+            <a:avLst/>
+          </a:prstGeom>
+          <a:solidFill>
+            <a:srgbClr val="FFFFFF">
+              <a:alpha val="0"/>
+            </a:srgbClr>
+          </a:solidFill>
+          <a:ln w="7620">
+            <a:solidFill>
+              <a:srgbClr val="D6DEE8"/>
+            </a:solidFill>
+            <a:prstDash val="solid"/>
+          </a:ln>
+        </p:spPr>
       </p:sp>
     </p:spTree>
   </p:cSld>
@@ -19944,8 +21189,8 @@
         </p:nvSpPr>
         <p:spPr>
           <a:xfrm>
-            <a:off x="7635240" y="6528816"/>
-            <a:ext cx="3977640" cy="164592"/>
+            <a:off x="6720840" y="6528816"/>
+            <a:ext cx="4069080" cy="164592"/>
           </a:xfrm>
           <a:prstGeom prst="rect">
             <a:avLst/>
@@ -20882,6 +22127,89 @@
             <a:endParaRPr lang="en-US" sz="710" dirty="0"/>
           </a:p>
         </p:txBody>
+      </p:sp>
+      <p:sp>
+        <p:nvSpPr>
+          <p:cNvPr id="33" name="Shape 31"/>
+          <p:cNvSpPr/>
+          <p:nvPr/>
+        </p:nvSpPr>
+        <p:spPr>
+          <a:xfrm>
+            <a:off x="11155680" y="5632704"/>
+            <a:ext cx="841248" cy="841248"/>
+          </a:xfrm>
+          <a:prstGeom prst="ellipse">
+            <a:avLst/>
+          </a:prstGeom>
+          <a:solidFill>
+            <a:srgbClr val="1B2430">
+              <a:alpha val="14000"/>
+            </a:srgbClr>
+          </a:solidFill>
+          <a:ln w="12700">
+            <a:solidFill>
+              <a:srgbClr val="1B2430">
+                <a:alpha val="0"/>
+              </a:srgbClr>
+            </a:solidFill>
+            <a:prstDash val="solid"/>
+          </a:ln>
+        </p:spPr>
+      </p:sp>
+      <p:sp>
+        <p:nvSpPr>
+          <p:cNvPr id="34" name="Shape 32"/>
+          <p:cNvSpPr/>
+          <p:nvPr/>
+        </p:nvSpPr>
+        <p:spPr>
+          <a:xfrm>
+            <a:off x="11100816" y="5577840"/>
+            <a:ext cx="822960" cy="822960"/>
+          </a:xfrm>
+          <a:prstGeom prst="ellipse">
+            <a:avLst/>
+          </a:prstGeom>
+          <a:solidFill>
+            <a:srgbClr val="FFFFFF">
+              <a:alpha val="94000"/>
+            </a:srgbClr>
+          </a:solidFill>
+          <a:ln w="15240">
+            <a:solidFill>
+              <a:srgbClr val="1F7A8C"/>
+            </a:solidFill>
+            <a:prstDash val="solid"/>
+          </a:ln>
+        </p:spPr>
+      </p:sp>
+      <p:sp>
+        <p:nvSpPr>
+          <p:cNvPr id="35" name="Shape 33"/>
+          <p:cNvSpPr/>
+          <p:nvPr/>
+        </p:nvSpPr>
+        <p:spPr>
+          <a:xfrm>
+            <a:off x="11247120" y="5724144"/>
+            <a:ext cx="530352" cy="530352"/>
+          </a:xfrm>
+          <a:prstGeom prst="ellipse">
+            <a:avLst/>
+          </a:prstGeom>
+          <a:solidFill>
+            <a:srgbClr val="FFFFFF">
+              <a:alpha val="0"/>
+            </a:srgbClr>
+          </a:solidFill>
+          <a:ln w="7620">
+            <a:solidFill>
+              <a:srgbClr val="D6DEE8"/>
+            </a:solidFill>
+            <a:prstDash val="solid"/>
+          </a:ln>
+        </p:spPr>
       </p:sp>
     </p:spTree>
   </p:cSld>

</xml_diff>